<commit_message>
Embed full infographic and column images in PPT slide 1 and 2
Co-authored-by: Junwei Wang <junweiwangwjw@icloud.com>
</commit_message>
<xml_diff>
--- a/AI-industry-chain-editable.pptx
+++ b/AI-industry-chain-editable.pptx
@@ -3089,12 +3089,20 @@
         <p:nvPr/>
       </p:nvGrpSpPr>
       <p:grpSpPr/>
-      <p:sp>
-        <p:nvSpPr>
-          <p:cNvPr id="2" name="Rectangle 1"/>
-          <p:cNvSpPr/>
+      <p:pic>
+        <p:nvPicPr>
+          <p:cNvPr id="2" name="Picture 1" descr="ai-industry-chain-infographic-zh.png"/>
+          <p:cNvPicPr>
+            <a:picLocks noChangeAspect="1"/>
+          </p:cNvPicPr>
           <p:nvPr/>
-        </p:nvSpPr>
+        </p:nvPicPr>
+        <p:blipFill>
+          <a:blip r:embed="rId2"/>
+          <a:stretch>
+            <a:fillRect/>
+          </a:stretch>
+        </p:blipFill>
         <p:spPr>
           <a:xfrm>
             <a:off x="0" y="0"/>
@@ -3103,1965 +3111,8 @@
           <a:prstGeom prst="rect">
             <a:avLst/>
           </a:prstGeom>
-          <a:solidFill>
-            <a:srgbClr val="0A1628"/>
-          </a:solidFill>
-          <a:ln>
-            <a:noFill/>
-          </a:ln>
-        </p:spPr>
-        <p:style>
-          <a:lnRef idx="1">
-            <a:schemeClr val="accent1"/>
-          </a:lnRef>
-          <a:fillRef idx="3">
-            <a:schemeClr val="accent1"/>
-          </a:fillRef>
-          <a:effectRef idx="2">
-            <a:schemeClr val="accent1"/>
-          </a:effectRef>
-          <a:fontRef idx="minor">
-            <a:schemeClr val="lt1"/>
-          </a:fontRef>
-        </p:style>
-        <p:txBody>
-          <a:bodyPr rtlCol="0" anchor="ctr"/>
-          <a:lstStyle/>
-          <a:p>
-            <a:pPr algn="ctr"/>
-          </a:p>
-        </p:txBody>
-      </p:sp>
-      <p:sp>
-        <p:nvSpPr>
-          <p:cNvPr id="3" name="Rectangle 2"/>
-          <p:cNvSpPr/>
-          <p:nvPr/>
-        </p:nvSpPr>
-        <p:spPr>
-          <a:xfrm>
-            <a:off x="0" y="0"/>
-            <a:ext cx="12191695" cy="1417320"/>
-          </a:xfrm>
-          <a:prstGeom prst="rect">
-            <a:avLst/>
-          </a:prstGeom>
-          <a:solidFill>
-            <a:srgbClr val="12233C"/>
-          </a:solidFill>
-          <a:ln>
-            <a:noFill/>
-          </a:ln>
-        </p:spPr>
-        <p:style>
-          <a:lnRef idx="1">
-            <a:schemeClr val="accent1"/>
-          </a:lnRef>
-          <a:fillRef idx="3">
-            <a:schemeClr val="accent1"/>
-          </a:fillRef>
-          <a:effectRef idx="2">
-            <a:schemeClr val="accent1"/>
-          </a:effectRef>
-          <a:fontRef idx="minor">
-            <a:schemeClr val="lt1"/>
-          </a:fontRef>
-        </p:style>
-        <p:txBody>
-          <a:bodyPr rtlCol="0" anchor="ctr"/>
-          <a:lstStyle/>
-          <a:p>
-            <a:pPr algn="ctr"/>
-          </a:p>
-        </p:txBody>
-      </p:sp>
-      <p:sp>
-        <p:nvSpPr>
-          <p:cNvPr id="4" name="TextBox 3"/>
-          <p:cNvSpPr txBox="1"/>
-          <p:nvPr/>
-        </p:nvSpPr>
-        <p:spPr>
-          <a:xfrm>
-            <a:off x="411480" y="256032"/>
-            <a:ext cx="10972800" cy="594360"/>
-          </a:xfrm>
-          <a:prstGeom prst="rect">
-            <a:avLst/>
-          </a:prstGeom>
-          <a:noFill/>
-        </p:spPr>
-        <p:txBody>
-          <a:bodyPr wrap="square" anchor="t">
-            <a:spAutoFit/>
-          </a:bodyPr>
-          <a:lstStyle/>
-          <a:p>
-            <a:pPr algn="l">
-              <a:defRPr sz="2800" b="1">
-                <a:solidFill>
-                  <a:srgbClr val="FFFFFF"/>
-                </a:solidFill>
-                <a:latin typeface="Microsoft YaHei"/>
-              </a:defRPr>
-            </a:pPr>
-            <a:r>
-              <a:t>做 AI 投资？最大的差异不是模型，而是产业链。</a:t>
-            </a:r>
-          </a:p>
-        </p:txBody>
-      </p:sp>
-      <p:sp>
-        <p:nvSpPr>
-          <p:cNvPr id="5" name="TextBox 4"/>
-          <p:cNvSpPr txBox="1"/>
-          <p:nvPr/>
-        </p:nvSpPr>
-        <p:spPr>
-          <a:xfrm>
-            <a:off x="411480" y="868680"/>
-            <a:ext cx="10972800" cy="365760"/>
-          </a:xfrm>
-          <a:prstGeom prst="rect">
-            <a:avLst/>
-          </a:prstGeom>
-          <a:noFill/>
-        </p:spPr>
-        <p:txBody>
-          <a:bodyPr wrap="square" anchor="t">
-            <a:spAutoFit/>
-          </a:bodyPr>
-          <a:lstStyle/>
-          <a:p>
-            <a:pPr algn="l">
-              <a:defRPr sz="1600" b="0">
-                <a:solidFill>
-                  <a:srgbClr val="B4BED2"/>
-                </a:solidFill>
-                <a:latin typeface="Microsoft YaHei"/>
-              </a:defRPr>
-            </a:pPr>
-            <a:r>
-              <a:t>五层结构，一条链条，价值从芯片流向应用。</a:t>
-            </a:r>
-          </a:p>
-        </p:txBody>
-      </p:sp>
-      <p:sp>
-        <p:nvSpPr>
-          <p:cNvPr id="6" name="Rounded Rectangle 5"/>
-          <p:cNvSpPr/>
-          <p:nvPr/>
-        </p:nvSpPr>
-        <p:spPr>
-          <a:xfrm>
-            <a:off x="320040" y="1600200"/>
-            <a:ext cx="2178649" cy="3977639"/>
-          </a:xfrm>
-          <a:prstGeom prst="roundRect">
-            <a:avLst/>
-          </a:prstGeom>
-          <a:solidFill>
-            <a:srgbClr val="0E1C32"/>
-          </a:solidFill>
-          <a:ln w="12700">
-            <a:solidFill>
-              <a:srgbClr val="1E375A"/>
-            </a:solidFill>
-          </a:ln>
-        </p:spPr>
-        <p:style>
-          <a:lnRef idx="1">
-            <a:schemeClr val="accent1"/>
-          </a:lnRef>
-          <a:fillRef idx="3">
-            <a:schemeClr val="accent1"/>
-          </a:fillRef>
-          <a:effectRef idx="2">
-            <a:schemeClr val="accent1"/>
-          </a:effectRef>
-          <a:fontRef idx="minor">
-            <a:schemeClr val="lt1"/>
-          </a:fontRef>
-        </p:style>
-        <p:txBody>
-          <a:bodyPr rtlCol="0" anchor="ctr"/>
-          <a:lstStyle/>
-          <a:p>
-            <a:pPr algn="ctr"/>
-          </a:p>
-        </p:txBody>
-      </p:sp>
-      <p:sp>
-        <p:nvSpPr>
-          <p:cNvPr id="7" name="TextBox 6"/>
-          <p:cNvSpPr txBox="1"/>
-          <p:nvPr/>
-        </p:nvSpPr>
-        <p:spPr>
-          <a:xfrm>
-            <a:off x="429768" y="1737360"/>
-            <a:ext cx="1959193" cy="411480"/>
-          </a:xfrm>
-          <a:prstGeom prst="rect">
-            <a:avLst/>
-          </a:prstGeom>
-          <a:noFill/>
-        </p:spPr>
-        <p:txBody>
-          <a:bodyPr wrap="square" anchor="t">
-            <a:spAutoFit/>
-          </a:bodyPr>
-          <a:lstStyle/>
-          <a:p>
-            <a:pPr algn="ctr">
-              <a:defRPr sz="2000" b="1">
-                <a:solidFill>
-                  <a:srgbClr val="FFFFFF"/>
-                </a:solidFill>
-                <a:latin typeface="Microsoft YaHei"/>
-              </a:defRPr>
-            </a:pPr>
-            <a:r>
-              <a:t>算力层</a:t>
-            </a:r>
-          </a:p>
-        </p:txBody>
-      </p:sp>
-      <p:sp>
-        <p:nvSpPr>
-          <p:cNvPr id="8" name="TextBox 7"/>
-          <p:cNvSpPr txBox="1"/>
-          <p:nvPr/>
-        </p:nvSpPr>
-        <p:spPr>
-          <a:xfrm>
-            <a:off x="411480" y="2167128"/>
-            <a:ext cx="1995769" cy="685800"/>
-          </a:xfrm>
-          <a:prstGeom prst="rect">
-            <a:avLst/>
-          </a:prstGeom>
-          <a:noFill/>
-        </p:spPr>
-        <p:txBody>
-          <a:bodyPr wrap="square" anchor="t">
-            <a:spAutoFit/>
-          </a:bodyPr>
-          <a:lstStyle/>
-          <a:p>
-            <a:pPr algn="ctr">
-              <a:defRPr sz="1200" b="0">
-                <a:solidFill>
-                  <a:srgbClr val="B4BED2"/>
-                </a:solidFill>
-                <a:latin typeface="Microsoft YaHei"/>
-              </a:defRPr>
-            </a:pPr>
-            <a:r>
-              <a:t>生于硅片，GPU 与 HBM</a:t>
-            </a:r>
-            <a:br/>
-            <a:r>
-              <a:t>驱动一切。</a:t>
-            </a:r>
-          </a:p>
-        </p:txBody>
-      </p:sp>
-      <p:sp>
-        <p:nvSpPr>
-          <p:cNvPr id="9" name="Oval 8"/>
-          <p:cNvSpPr/>
-          <p:nvPr/>
-        </p:nvSpPr>
-        <p:spPr>
-          <a:xfrm>
-            <a:off x="1080180" y="3017520"/>
-            <a:ext cx="658368" cy="658368"/>
-          </a:xfrm>
-          <a:prstGeom prst="ellipse">
-            <a:avLst/>
-          </a:prstGeom>
-          <a:solidFill>
-            <a:srgbClr val="3B82F6"/>
-          </a:solidFill>
-          <a:ln>
-            <a:noFill/>
-          </a:ln>
-        </p:spPr>
-        <p:style>
-          <a:lnRef idx="1">
-            <a:schemeClr val="accent1"/>
-          </a:lnRef>
-          <a:fillRef idx="3">
-            <a:schemeClr val="accent1"/>
-          </a:fillRef>
-          <a:effectRef idx="2">
-            <a:schemeClr val="accent1"/>
-          </a:effectRef>
-          <a:fontRef idx="minor">
-            <a:schemeClr val="lt1"/>
-          </a:fontRef>
-        </p:style>
-        <p:txBody>
-          <a:bodyPr rtlCol="0" anchor="ctr"/>
-          <a:lstStyle/>
-          <a:p>
-            <a:pPr algn="ctr"/>
-          </a:p>
-        </p:txBody>
-      </p:sp>
-      <p:sp>
-        <p:nvSpPr>
-          <p:cNvPr id="10" name="TextBox 9"/>
-          <p:cNvSpPr txBox="1"/>
-          <p:nvPr/>
-        </p:nvSpPr>
-        <p:spPr>
-          <a:xfrm>
-            <a:off x="1080180" y="3127248"/>
-            <a:ext cx="658368" cy="438912"/>
-          </a:xfrm>
-          <a:prstGeom prst="rect">
-            <a:avLst/>
-          </a:prstGeom>
-          <a:noFill/>
-        </p:spPr>
-        <p:txBody>
-          <a:bodyPr wrap="none" anchor="ctr">
-            <a:spAutoFit/>
-          </a:bodyPr>
-          <a:lstStyle/>
-          <a:p>
-            <a:pPr algn="ctr">
-              <a:defRPr sz="2200" b="1">
-                <a:solidFill>
-                  <a:srgbClr val="FFFFFF"/>
-                </a:solidFill>
-                <a:latin typeface="Microsoft YaHei"/>
-              </a:defRPr>
-            </a:pPr>
-            <a:r>
-              <a:t>芯</a:t>
-            </a:r>
-          </a:p>
-        </p:txBody>
-      </p:sp>
-      <p:sp>
-        <p:nvSpPr>
-          <p:cNvPr id="11" name="Rounded Rectangle 10"/>
-          <p:cNvSpPr/>
-          <p:nvPr/>
-        </p:nvSpPr>
-        <p:spPr>
-          <a:xfrm>
-            <a:off x="457200" y="3840480"/>
-            <a:ext cx="1904329" cy="1508760"/>
-          </a:xfrm>
-          <a:prstGeom prst="roundRect">
-            <a:avLst/>
-          </a:prstGeom>
-          <a:solidFill>
-            <a:srgbClr val="162844"/>
-          </a:solidFill>
-          <a:ln w="9525">
-            <a:solidFill>
-              <a:srgbClr val="2D4B78"/>
-            </a:solidFill>
-          </a:ln>
-        </p:spPr>
-        <p:style>
-          <a:lnRef idx="1">
-            <a:schemeClr val="accent1"/>
-          </a:lnRef>
-          <a:fillRef idx="3">
-            <a:schemeClr val="accent1"/>
-          </a:fillRef>
-          <a:effectRef idx="2">
-            <a:schemeClr val="accent1"/>
-          </a:effectRef>
-          <a:fontRef idx="minor">
-            <a:schemeClr val="lt1"/>
-          </a:fontRef>
-        </p:style>
-        <p:txBody>
-          <a:bodyPr rtlCol="0" anchor="ctr"/>
-          <a:lstStyle/>
-          <a:p>
-            <a:pPr algn="ctr"/>
-          </a:p>
-        </p:txBody>
-      </p:sp>
-      <p:sp>
-        <p:nvSpPr>
-          <p:cNvPr id="12" name="TextBox 11"/>
-          <p:cNvSpPr txBox="1"/>
-          <p:nvPr/>
-        </p:nvSpPr>
-        <p:spPr>
-          <a:xfrm>
-            <a:off x="457200" y="4343400"/>
-            <a:ext cx="1904329" cy="457200"/>
-          </a:xfrm>
-          <a:prstGeom prst="rect">
-            <a:avLst/>
-          </a:prstGeom>
-          <a:noFill/>
-        </p:spPr>
-        <p:txBody>
-          <a:bodyPr wrap="square" anchor="t">
-            <a:spAutoFit/>
-          </a:bodyPr>
-          <a:lstStyle/>
-          <a:p>
-            <a:pPr algn="ctr">
-              <a:defRPr sz="1000" b="0">
-                <a:solidFill>
-                  <a:srgbClr val="6482AA"/>
-                </a:solidFill>
-                <a:latin typeface="Microsoft YaHei"/>
-              </a:defRPr>
-            </a:pPr>
-            <a:r>
-              <a:t>← 可替换图片</a:t>
-            </a:r>
-          </a:p>
-        </p:txBody>
-      </p:sp>
-      <p:sp>
-        <p:nvSpPr>
-          <p:cNvPr id="13" name="Rounded Rectangle 12"/>
-          <p:cNvSpPr/>
-          <p:nvPr/>
-        </p:nvSpPr>
-        <p:spPr>
-          <a:xfrm>
-            <a:off x="2663281" y="1600200"/>
-            <a:ext cx="2178649" cy="3977639"/>
-          </a:xfrm>
-          <a:prstGeom prst="roundRect">
-            <a:avLst/>
-          </a:prstGeom>
-          <a:solidFill>
-            <a:srgbClr val="0E1C32"/>
-          </a:solidFill>
-          <a:ln w="12700">
-            <a:solidFill>
-              <a:srgbClr val="1E375A"/>
-            </a:solidFill>
-          </a:ln>
-        </p:spPr>
-        <p:style>
-          <a:lnRef idx="1">
-            <a:schemeClr val="accent1"/>
-          </a:lnRef>
-          <a:fillRef idx="3">
-            <a:schemeClr val="accent1"/>
-          </a:fillRef>
-          <a:effectRef idx="2">
-            <a:schemeClr val="accent1"/>
-          </a:effectRef>
-          <a:fontRef idx="minor">
-            <a:schemeClr val="lt1"/>
-          </a:fontRef>
-        </p:style>
-        <p:txBody>
-          <a:bodyPr rtlCol="0" anchor="ctr"/>
-          <a:lstStyle/>
-          <a:p>
-            <a:pPr algn="ctr"/>
-          </a:p>
-        </p:txBody>
-      </p:sp>
-      <p:sp>
-        <p:nvSpPr>
-          <p:cNvPr id="14" name="TextBox 13"/>
-          <p:cNvSpPr txBox="1"/>
-          <p:nvPr/>
-        </p:nvSpPr>
-        <p:spPr>
-          <a:xfrm>
-            <a:off x="2773009" y="1737360"/>
-            <a:ext cx="1959193" cy="411480"/>
-          </a:xfrm>
-          <a:prstGeom prst="rect">
-            <a:avLst/>
-          </a:prstGeom>
-          <a:noFill/>
-        </p:spPr>
-        <p:txBody>
-          <a:bodyPr wrap="square" anchor="t">
-            <a:spAutoFit/>
-          </a:bodyPr>
-          <a:lstStyle/>
-          <a:p>
-            <a:pPr algn="ctr">
-              <a:defRPr sz="2000" b="1">
-                <a:solidFill>
-                  <a:srgbClr val="FFFFFF"/>
-                </a:solidFill>
-                <a:latin typeface="Microsoft YaHei"/>
-              </a:defRPr>
-            </a:pPr>
-            <a:r>
-              <a:t>基础设施层</a:t>
-            </a:r>
-          </a:p>
-        </p:txBody>
-      </p:sp>
-      <p:sp>
-        <p:nvSpPr>
-          <p:cNvPr id="15" name="TextBox 14"/>
-          <p:cNvSpPr txBox="1"/>
-          <p:nvPr/>
-        </p:nvSpPr>
-        <p:spPr>
-          <a:xfrm>
-            <a:off x="2754721" y="2167128"/>
-            <a:ext cx="1995769" cy="685800"/>
-          </a:xfrm>
-          <a:prstGeom prst="rect">
-            <a:avLst/>
-          </a:prstGeom>
-          <a:noFill/>
-        </p:spPr>
-        <p:txBody>
-          <a:bodyPr wrap="square" anchor="t">
-            <a:spAutoFit/>
-          </a:bodyPr>
-          <a:lstStyle/>
-          <a:p>
-            <a:pPr algn="ctr">
-              <a:defRPr sz="1200" b="0">
-                <a:solidFill>
-                  <a:srgbClr val="B4BED2"/>
-                </a:solidFill>
-                <a:latin typeface="Microsoft YaHei"/>
-              </a:defRPr>
-            </a:pPr>
-            <a:r>
-              <a:t>电力、液冷与万卡</a:t>
-            </a:r>
-            <a:br/>
-            <a:r>
-              <a:t>集群规模化。</a:t>
-            </a:r>
-          </a:p>
-        </p:txBody>
-      </p:sp>
-      <p:sp>
-        <p:nvSpPr>
-          <p:cNvPr id="16" name="Oval 15"/>
-          <p:cNvSpPr/>
-          <p:nvPr/>
-        </p:nvSpPr>
-        <p:spPr>
-          <a:xfrm>
-            <a:off x="3423421" y="3017520"/>
-            <a:ext cx="658368" cy="658368"/>
-          </a:xfrm>
-          <a:prstGeom prst="ellipse">
-            <a:avLst/>
-          </a:prstGeom>
-          <a:solidFill>
-            <a:srgbClr val="3B82F6"/>
-          </a:solidFill>
-          <a:ln>
-            <a:noFill/>
-          </a:ln>
-        </p:spPr>
-        <p:style>
-          <a:lnRef idx="1">
-            <a:schemeClr val="accent1"/>
-          </a:lnRef>
-          <a:fillRef idx="3">
-            <a:schemeClr val="accent1"/>
-          </a:fillRef>
-          <a:effectRef idx="2">
-            <a:schemeClr val="accent1"/>
-          </a:effectRef>
-          <a:fontRef idx="minor">
-            <a:schemeClr val="lt1"/>
-          </a:fontRef>
-        </p:style>
-        <p:txBody>
-          <a:bodyPr rtlCol="0" anchor="ctr"/>
-          <a:lstStyle/>
-          <a:p>
-            <a:pPr algn="ctr"/>
-          </a:p>
-        </p:txBody>
-      </p:sp>
-      <p:sp>
-        <p:nvSpPr>
-          <p:cNvPr id="17" name="TextBox 16"/>
-          <p:cNvSpPr txBox="1"/>
-          <p:nvPr/>
-        </p:nvSpPr>
-        <p:spPr>
-          <a:xfrm>
-            <a:off x="3423421" y="3127248"/>
-            <a:ext cx="658368" cy="438912"/>
-          </a:xfrm>
-          <a:prstGeom prst="rect">
-            <a:avLst/>
-          </a:prstGeom>
-          <a:noFill/>
-        </p:spPr>
-        <p:txBody>
-          <a:bodyPr wrap="none" anchor="ctr">
-            <a:spAutoFit/>
-          </a:bodyPr>
-          <a:lstStyle/>
-          <a:p>
-            <a:pPr algn="ctr">
-              <a:defRPr sz="2200" b="1">
-                <a:solidFill>
-                  <a:srgbClr val="FFFFFF"/>
-                </a:solidFill>
-                <a:latin typeface="Microsoft YaHei"/>
-              </a:defRPr>
-            </a:pPr>
-            <a:r>
-              <a:t>云</a:t>
-            </a:r>
-          </a:p>
-        </p:txBody>
-      </p:sp>
-      <p:sp>
-        <p:nvSpPr>
-          <p:cNvPr id="18" name="Rounded Rectangle 17"/>
-          <p:cNvSpPr/>
-          <p:nvPr/>
-        </p:nvSpPr>
-        <p:spPr>
-          <a:xfrm>
-            <a:off x="2800441" y="3840480"/>
-            <a:ext cx="1904329" cy="1508760"/>
-          </a:xfrm>
-          <a:prstGeom prst="roundRect">
-            <a:avLst/>
-          </a:prstGeom>
-          <a:solidFill>
-            <a:srgbClr val="162844"/>
-          </a:solidFill>
-          <a:ln w="9525">
-            <a:solidFill>
-              <a:srgbClr val="2D4B78"/>
-            </a:solidFill>
-          </a:ln>
-        </p:spPr>
-        <p:style>
-          <a:lnRef idx="1">
-            <a:schemeClr val="accent1"/>
-          </a:lnRef>
-          <a:fillRef idx="3">
-            <a:schemeClr val="accent1"/>
-          </a:fillRef>
-          <a:effectRef idx="2">
-            <a:schemeClr val="accent1"/>
-          </a:effectRef>
-          <a:fontRef idx="minor">
-            <a:schemeClr val="lt1"/>
-          </a:fontRef>
-        </p:style>
-        <p:txBody>
-          <a:bodyPr rtlCol="0" anchor="ctr"/>
-          <a:lstStyle/>
-          <a:p>
-            <a:pPr algn="ctr"/>
-          </a:p>
-        </p:txBody>
-      </p:sp>
-      <p:sp>
-        <p:nvSpPr>
-          <p:cNvPr id="19" name="TextBox 18"/>
-          <p:cNvSpPr txBox="1"/>
-          <p:nvPr/>
-        </p:nvSpPr>
-        <p:spPr>
-          <a:xfrm>
-            <a:off x="2800441" y="4343400"/>
-            <a:ext cx="1904329" cy="457200"/>
-          </a:xfrm>
-          <a:prstGeom prst="rect">
-            <a:avLst/>
-          </a:prstGeom>
-          <a:noFill/>
-        </p:spPr>
-        <p:txBody>
-          <a:bodyPr wrap="square" anchor="t">
-            <a:spAutoFit/>
-          </a:bodyPr>
-          <a:lstStyle/>
-          <a:p>
-            <a:pPr algn="ctr">
-              <a:defRPr sz="1000" b="0">
-                <a:solidFill>
-                  <a:srgbClr val="6482AA"/>
-                </a:solidFill>
-                <a:latin typeface="Microsoft YaHei"/>
-              </a:defRPr>
-            </a:pPr>
-            <a:r>
-              <a:t>← 可替换图片</a:t>
-            </a:r>
-          </a:p>
-        </p:txBody>
-      </p:sp>
-      <p:sp>
-        <p:nvSpPr>
-          <p:cNvPr id="20" name="Rounded Rectangle 19"/>
-          <p:cNvSpPr/>
-          <p:nvPr/>
-        </p:nvSpPr>
-        <p:spPr>
-          <a:xfrm>
-            <a:off x="5006522" y="1600200"/>
-            <a:ext cx="2178649" cy="3977639"/>
-          </a:xfrm>
-          <a:prstGeom prst="roundRect">
-            <a:avLst/>
-          </a:prstGeom>
-          <a:solidFill>
-            <a:srgbClr val="0E1C32"/>
-          </a:solidFill>
-          <a:ln w="12700">
-            <a:solidFill>
-              <a:srgbClr val="1E375A"/>
-            </a:solidFill>
-          </a:ln>
-        </p:spPr>
-        <p:style>
-          <a:lnRef idx="1">
-            <a:schemeClr val="accent1"/>
-          </a:lnRef>
-          <a:fillRef idx="3">
-            <a:schemeClr val="accent1"/>
-          </a:fillRef>
-          <a:effectRef idx="2">
-            <a:schemeClr val="accent1"/>
-          </a:effectRef>
-          <a:fontRef idx="minor">
-            <a:schemeClr val="lt1"/>
-          </a:fontRef>
-        </p:style>
-        <p:txBody>
-          <a:bodyPr rtlCol="0" anchor="ctr"/>
-          <a:lstStyle/>
-          <a:p>
-            <a:pPr algn="ctr"/>
-          </a:p>
-        </p:txBody>
-      </p:sp>
-      <p:sp>
-        <p:nvSpPr>
-          <p:cNvPr id="21" name="TextBox 20"/>
-          <p:cNvSpPr txBox="1"/>
-          <p:nvPr/>
-        </p:nvSpPr>
-        <p:spPr>
-          <a:xfrm>
-            <a:off x="5116250" y="1737360"/>
-            <a:ext cx="1959193" cy="411480"/>
-          </a:xfrm>
-          <a:prstGeom prst="rect">
-            <a:avLst/>
-          </a:prstGeom>
-          <a:noFill/>
-        </p:spPr>
-        <p:txBody>
-          <a:bodyPr wrap="square" anchor="t">
-            <a:spAutoFit/>
-          </a:bodyPr>
-          <a:lstStyle/>
-          <a:p>
-            <a:pPr algn="ctr">
-              <a:defRPr sz="2000" b="1">
-                <a:solidFill>
-                  <a:srgbClr val="FFFFFF"/>
-                </a:solidFill>
-                <a:latin typeface="Microsoft YaHei"/>
-              </a:defRPr>
-            </a:pPr>
-            <a:r>
-              <a:t>模型层</a:t>
-            </a:r>
-          </a:p>
-        </p:txBody>
-      </p:sp>
-      <p:sp>
-        <p:nvSpPr>
-          <p:cNvPr id="22" name="TextBox 21"/>
-          <p:cNvSpPr txBox="1"/>
-          <p:nvPr/>
-        </p:nvSpPr>
-        <p:spPr>
-          <a:xfrm>
-            <a:off x="5097962" y="2167128"/>
-            <a:ext cx="1995769" cy="685800"/>
-          </a:xfrm>
-          <a:prstGeom prst="rect">
-            <a:avLst/>
-          </a:prstGeom>
-          <a:noFill/>
-        </p:spPr>
-        <p:txBody>
-          <a:bodyPr wrap="square" anchor="t">
-            <a:spAutoFit/>
-          </a:bodyPr>
-          <a:lstStyle/>
-          <a:p>
-            <a:pPr algn="ctr">
-              <a:defRPr sz="1200" b="0">
-                <a:solidFill>
-                  <a:srgbClr val="B4BED2"/>
-                </a:solidFill>
-                <a:latin typeface="Microsoft YaHei"/>
-              </a:defRPr>
-            </a:pPr>
-            <a:r>
-              <a:t>数据训练，算力炼成</a:t>
-            </a:r>
-            <a:br/>
-            <a:r>
-              <a:t>认知能力。</a:t>
-            </a:r>
-          </a:p>
-        </p:txBody>
-      </p:sp>
-      <p:sp>
-        <p:nvSpPr>
-          <p:cNvPr id="23" name="Oval 22"/>
-          <p:cNvSpPr/>
-          <p:nvPr/>
-        </p:nvSpPr>
-        <p:spPr>
-          <a:xfrm>
-            <a:off x="5766662" y="3017520"/>
-            <a:ext cx="658368" cy="658368"/>
-          </a:xfrm>
-          <a:prstGeom prst="ellipse">
-            <a:avLst/>
-          </a:prstGeom>
-          <a:solidFill>
-            <a:srgbClr val="3B82F6"/>
-          </a:solidFill>
-          <a:ln>
-            <a:noFill/>
-          </a:ln>
-        </p:spPr>
-        <p:style>
-          <a:lnRef idx="1">
-            <a:schemeClr val="accent1"/>
-          </a:lnRef>
-          <a:fillRef idx="3">
-            <a:schemeClr val="accent1"/>
-          </a:fillRef>
-          <a:effectRef idx="2">
-            <a:schemeClr val="accent1"/>
-          </a:effectRef>
-          <a:fontRef idx="minor">
-            <a:schemeClr val="lt1"/>
-          </a:fontRef>
-        </p:style>
-        <p:txBody>
-          <a:bodyPr rtlCol="0" anchor="ctr"/>
-          <a:lstStyle/>
-          <a:p>
-            <a:pPr algn="ctr"/>
-          </a:p>
-        </p:txBody>
-      </p:sp>
-      <p:sp>
-        <p:nvSpPr>
-          <p:cNvPr id="24" name="TextBox 23"/>
-          <p:cNvSpPr txBox="1"/>
-          <p:nvPr/>
-        </p:nvSpPr>
-        <p:spPr>
-          <a:xfrm>
-            <a:off x="5766662" y="3127248"/>
-            <a:ext cx="658368" cy="438912"/>
-          </a:xfrm>
-          <a:prstGeom prst="rect">
-            <a:avLst/>
-          </a:prstGeom>
-          <a:noFill/>
-        </p:spPr>
-        <p:txBody>
-          <a:bodyPr wrap="none" anchor="ctr">
-            <a:spAutoFit/>
-          </a:bodyPr>
-          <a:lstStyle/>
-          <a:p>
-            <a:pPr algn="ctr">
-              <a:defRPr sz="2200" b="1">
-                <a:solidFill>
-                  <a:srgbClr val="FFFFFF"/>
-                </a:solidFill>
-                <a:latin typeface="Microsoft YaHei"/>
-              </a:defRPr>
-            </a:pPr>
-            <a:r>
-              <a:t>脑</a:t>
-            </a:r>
-          </a:p>
-        </p:txBody>
-      </p:sp>
-      <p:sp>
-        <p:nvSpPr>
-          <p:cNvPr id="25" name="Rounded Rectangle 24"/>
-          <p:cNvSpPr/>
-          <p:nvPr/>
-        </p:nvSpPr>
-        <p:spPr>
-          <a:xfrm>
-            <a:off x="5143682" y="3840480"/>
-            <a:ext cx="1904329" cy="1508760"/>
-          </a:xfrm>
-          <a:prstGeom prst="roundRect">
-            <a:avLst/>
-          </a:prstGeom>
-          <a:solidFill>
-            <a:srgbClr val="162844"/>
-          </a:solidFill>
-          <a:ln w="9525">
-            <a:solidFill>
-              <a:srgbClr val="2D4B78"/>
-            </a:solidFill>
-          </a:ln>
-        </p:spPr>
-        <p:style>
-          <a:lnRef idx="1">
-            <a:schemeClr val="accent1"/>
-          </a:lnRef>
-          <a:fillRef idx="3">
-            <a:schemeClr val="accent1"/>
-          </a:fillRef>
-          <a:effectRef idx="2">
-            <a:schemeClr val="accent1"/>
-          </a:effectRef>
-          <a:fontRef idx="minor">
-            <a:schemeClr val="lt1"/>
-          </a:fontRef>
-        </p:style>
-        <p:txBody>
-          <a:bodyPr rtlCol="0" anchor="ctr"/>
-          <a:lstStyle/>
-          <a:p>
-            <a:pPr algn="ctr"/>
-          </a:p>
-        </p:txBody>
-      </p:sp>
-      <p:sp>
-        <p:nvSpPr>
-          <p:cNvPr id="26" name="TextBox 25"/>
-          <p:cNvSpPr txBox="1"/>
-          <p:nvPr/>
-        </p:nvSpPr>
-        <p:spPr>
-          <a:xfrm>
-            <a:off x="5143682" y="4343400"/>
-            <a:ext cx="1904329" cy="457200"/>
-          </a:xfrm>
-          <a:prstGeom prst="rect">
-            <a:avLst/>
-          </a:prstGeom>
-          <a:noFill/>
-        </p:spPr>
-        <p:txBody>
-          <a:bodyPr wrap="square" anchor="t">
-            <a:spAutoFit/>
-          </a:bodyPr>
-          <a:lstStyle/>
-          <a:p>
-            <a:pPr algn="ctr">
-              <a:defRPr sz="1000" b="0">
-                <a:solidFill>
-                  <a:srgbClr val="6482AA"/>
-                </a:solidFill>
-                <a:latin typeface="Microsoft YaHei"/>
-              </a:defRPr>
-            </a:pPr>
-            <a:r>
-              <a:t>← 可替换图片</a:t>
-            </a:r>
-          </a:p>
-        </p:txBody>
-      </p:sp>
-      <p:sp>
-        <p:nvSpPr>
-          <p:cNvPr id="27" name="Rounded Rectangle 26"/>
-          <p:cNvSpPr/>
-          <p:nvPr/>
-        </p:nvSpPr>
-        <p:spPr>
-          <a:xfrm>
-            <a:off x="7349763" y="1600200"/>
-            <a:ext cx="2178649" cy="3977639"/>
-          </a:xfrm>
-          <a:prstGeom prst="roundRect">
-            <a:avLst/>
-          </a:prstGeom>
-          <a:solidFill>
-            <a:srgbClr val="0E1C32"/>
-          </a:solidFill>
-          <a:ln w="12700">
-            <a:solidFill>
-              <a:srgbClr val="1E375A"/>
-            </a:solidFill>
-          </a:ln>
-        </p:spPr>
-        <p:style>
-          <a:lnRef idx="1">
-            <a:schemeClr val="accent1"/>
-          </a:lnRef>
-          <a:fillRef idx="3">
-            <a:schemeClr val="accent1"/>
-          </a:fillRef>
-          <a:effectRef idx="2">
-            <a:schemeClr val="accent1"/>
-          </a:effectRef>
-          <a:fontRef idx="minor">
-            <a:schemeClr val="lt1"/>
-          </a:fontRef>
-        </p:style>
-        <p:txBody>
-          <a:bodyPr rtlCol="0" anchor="ctr"/>
-          <a:lstStyle/>
-          <a:p>
-            <a:pPr algn="ctr"/>
-          </a:p>
-        </p:txBody>
-      </p:sp>
-      <p:sp>
-        <p:nvSpPr>
-          <p:cNvPr id="28" name="TextBox 27"/>
-          <p:cNvSpPr txBox="1"/>
-          <p:nvPr/>
-        </p:nvSpPr>
-        <p:spPr>
-          <a:xfrm>
-            <a:off x="7459491" y="1737360"/>
-            <a:ext cx="1959193" cy="411480"/>
-          </a:xfrm>
-          <a:prstGeom prst="rect">
-            <a:avLst/>
-          </a:prstGeom>
-          <a:noFill/>
-        </p:spPr>
-        <p:txBody>
-          <a:bodyPr wrap="square" anchor="t">
-            <a:spAutoFit/>
-          </a:bodyPr>
-          <a:lstStyle/>
-          <a:p>
-            <a:pPr algn="ctr">
-              <a:defRPr sz="2000" b="1">
-                <a:solidFill>
-                  <a:srgbClr val="FFFFFF"/>
-                </a:solidFill>
-                <a:latin typeface="Microsoft YaHei"/>
-              </a:defRPr>
-            </a:pPr>
-            <a:r>
-              <a:t>智能体层</a:t>
-            </a:r>
-          </a:p>
-        </p:txBody>
-      </p:sp>
-      <p:sp>
-        <p:nvSpPr>
-          <p:cNvPr id="29" name="TextBox 28"/>
-          <p:cNvSpPr txBox="1"/>
-          <p:nvPr/>
-        </p:nvSpPr>
-        <p:spPr>
-          <a:xfrm>
-            <a:off x="7441203" y="2167128"/>
-            <a:ext cx="1995769" cy="685800"/>
-          </a:xfrm>
-          <a:prstGeom prst="rect">
-            <a:avLst/>
-          </a:prstGeom>
-          <a:noFill/>
-        </p:spPr>
-        <p:txBody>
-          <a:bodyPr wrap="square" anchor="t">
-            <a:spAutoFit/>
-          </a:bodyPr>
-          <a:lstStyle/>
-          <a:p>
-            <a:pPr algn="ctr">
-              <a:defRPr sz="1200" b="0">
-                <a:solidFill>
-                  <a:srgbClr val="B4BED2"/>
-                </a:solidFill>
-                <a:latin typeface="Microsoft YaHei"/>
-              </a:defRPr>
-            </a:pPr>
-            <a:r>
-              <a:t>工具编排，自主规划</a:t>
-            </a:r>
-            <a:br/>
-            <a:r>
-              <a:t>与闭环执行。</a:t>
-            </a:r>
-          </a:p>
-        </p:txBody>
-      </p:sp>
-      <p:sp>
-        <p:nvSpPr>
-          <p:cNvPr id="30" name="Oval 29"/>
-          <p:cNvSpPr/>
-          <p:nvPr/>
-        </p:nvSpPr>
-        <p:spPr>
-          <a:xfrm>
-            <a:off x="8109903" y="3017520"/>
-            <a:ext cx="658368" cy="658368"/>
-          </a:xfrm>
-          <a:prstGeom prst="ellipse">
-            <a:avLst/>
-          </a:prstGeom>
-          <a:solidFill>
-            <a:srgbClr val="3B82F6"/>
-          </a:solidFill>
-          <a:ln>
-            <a:noFill/>
-          </a:ln>
-        </p:spPr>
-        <p:style>
-          <a:lnRef idx="1">
-            <a:schemeClr val="accent1"/>
-          </a:lnRef>
-          <a:fillRef idx="3">
-            <a:schemeClr val="accent1"/>
-          </a:fillRef>
-          <a:effectRef idx="2">
-            <a:schemeClr val="accent1"/>
-          </a:effectRef>
-          <a:fontRef idx="minor">
-            <a:schemeClr val="lt1"/>
-          </a:fontRef>
-        </p:style>
-        <p:txBody>
-          <a:bodyPr rtlCol="0" anchor="ctr"/>
-          <a:lstStyle/>
-          <a:p>
-            <a:pPr algn="ctr"/>
-          </a:p>
-        </p:txBody>
-      </p:sp>
-      <p:sp>
-        <p:nvSpPr>
-          <p:cNvPr id="31" name="TextBox 30"/>
-          <p:cNvSpPr txBox="1"/>
-          <p:nvPr/>
-        </p:nvSpPr>
-        <p:spPr>
-          <a:xfrm>
-            <a:off x="8109903" y="3127248"/>
-            <a:ext cx="658368" cy="438912"/>
-          </a:xfrm>
-          <a:prstGeom prst="rect">
-            <a:avLst/>
-          </a:prstGeom>
-          <a:noFill/>
-        </p:spPr>
-        <p:txBody>
-          <a:bodyPr wrap="none" anchor="ctr">
-            <a:spAutoFit/>
-          </a:bodyPr>
-          <a:lstStyle/>
-          <a:p>
-            <a:pPr algn="ctr">
-              <a:defRPr sz="2200" b="1">
-                <a:solidFill>
-                  <a:srgbClr val="FFFFFF"/>
-                </a:solidFill>
-                <a:latin typeface="Microsoft YaHei"/>
-              </a:defRPr>
-            </a:pPr>
-            <a:r>
-              <a:t>链</a:t>
-            </a:r>
-          </a:p>
-        </p:txBody>
-      </p:sp>
-      <p:sp>
-        <p:nvSpPr>
-          <p:cNvPr id="32" name="Rounded Rectangle 31"/>
-          <p:cNvSpPr/>
-          <p:nvPr/>
-        </p:nvSpPr>
-        <p:spPr>
-          <a:xfrm>
-            <a:off x="7486923" y="3840480"/>
-            <a:ext cx="1904329" cy="1508760"/>
-          </a:xfrm>
-          <a:prstGeom prst="roundRect">
-            <a:avLst/>
-          </a:prstGeom>
-          <a:solidFill>
-            <a:srgbClr val="162844"/>
-          </a:solidFill>
-          <a:ln w="9525">
-            <a:solidFill>
-              <a:srgbClr val="2D4B78"/>
-            </a:solidFill>
-          </a:ln>
-        </p:spPr>
-        <p:style>
-          <a:lnRef idx="1">
-            <a:schemeClr val="accent1"/>
-          </a:lnRef>
-          <a:fillRef idx="3">
-            <a:schemeClr val="accent1"/>
-          </a:fillRef>
-          <a:effectRef idx="2">
-            <a:schemeClr val="accent1"/>
-          </a:effectRef>
-          <a:fontRef idx="minor">
-            <a:schemeClr val="lt1"/>
-          </a:fontRef>
-        </p:style>
-        <p:txBody>
-          <a:bodyPr rtlCol="0" anchor="ctr"/>
-          <a:lstStyle/>
-          <a:p>
-            <a:pPr algn="ctr"/>
-          </a:p>
-        </p:txBody>
-      </p:sp>
-      <p:sp>
-        <p:nvSpPr>
-          <p:cNvPr id="33" name="TextBox 32"/>
-          <p:cNvSpPr txBox="1"/>
-          <p:nvPr/>
-        </p:nvSpPr>
-        <p:spPr>
-          <a:xfrm>
-            <a:off x="7486923" y="4343400"/>
-            <a:ext cx="1904329" cy="457200"/>
-          </a:xfrm>
-          <a:prstGeom prst="rect">
-            <a:avLst/>
-          </a:prstGeom>
-          <a:noFill/>
-        </p:spPr>
-        <p:txBody>
-          <a:bodyPr wrap="square" anchor="t">
-            <a:spAutoFit/>
-          </a:bodyPr>
-          <a:lstStyle/>
-          <a:p>
-            <a:pPr algn="ctr">
-              <a:defRPr sz="1000" b="0">
-                <a:solidFill>
-                  <a:srgbClr val="6482AA"/>
-                </a:solidFill>
-                <a:latin typeface="Microsoft YaHei"/>
-              </a:defRPr>
-            </a:pPr>
-            <a:r>
-              <a:t>← 可替换图片</a:t>
-            </a:r>
-          </a:p>
-        </p:txBody>
-      </p:sp>
-      <p:sp>
-        <p:nvSpPr>
-          <p:cNvPr id="34" name="Rounded Rectangle 33"/>
-          <p:cNvSpPr/>
-          <p:nvPr/>
-        </p:nvSpPr>
-        <p:spPr>
-          <a:xfrm>
-            <a:off x="9693004" y="1600200"/>
-            <a:ext cx="2178649" cy="3977639"/>
-          </a:xfrm>
-          <a:prstGeom prst="roundRect">
-            <a:avLst/>
-          </a:prstGeom>
-          <a:solidFill>
-            <a:srgbClr val="0E1C32"/>
-          </a:solidFill>
-          <a:ln w="12700">
-            <a:solidFill>
-              <a:srgbClr val="1E375A"/>
-            </a:solidFill>
-          </a:ln>
-        </p:spPr>
-        <p:style>
-          <a:lnRef idx="1">
-            <a:schemeClr val="accent1"/>
-          </a:lnRef>
-          <a:fillRef idx="3">
-            <a:schemeClr val="accent1"/>
-          </a:fillRef>
-          <a:effectRef idx="2">
-            <a:schemeClr val="accent1"/>
-          </a:effectRef>
-          <a:fontRef idx="minor">
-            <a:schemeClr val="lt1"/>
-          </a:fontRef>
-        </p:style>
-        <p:txBody>
-          <a:bodyPr rtlCol="0" anchor="ctr"/>
-          <a:lstStyle/>
-          <a:p>
-            <a:pPr algn="ctr"/>
-          </a:p>
-        </p:txBody>
-      </p:sp>
-      <p:sp>
-        <p:nvSpPr>
-          <p:cNvPr id="35" name="TextBox 34"/>
-          <p:cNvSpPr txBox="1"/>
-          <p:nvPr/>
-        </p:nvSpPr>
-        <p:spPr>
-          <a:xfrm>
-            <a:off x="9802732" y="1737360"/>
-            <a:ext cx="1959193" cy="411480"/>
-          </a:xfrm>
-          <a:prstGeom prst="rect">
-            <a:avLst/>
-          </a:prstGeom>
-          <a:noFill/>
-        </p:spPr>
-        <p:txBody>
-          <a:bodyPr wrap="square" anchor="t">
-            <a:spAutoFit/>
-          </a:bodyPr>
-          <a:lstStyle/>
-          <a:p>
-            <a:pPr algn="ctr">
-              <a:defRPr sz="2000" b="1">
-                <a:solidFill>
-                  <a:srgbClr val="FFFFFF"/>
-                </a:solidFill>
-                <a:latin typeface="Microsoft YaHei"/>
-              </a:defRPr>
-            </a:pPr>
-            <a:r>
-              <a:t>应用层</a:t>
-            </a:r>
-          </a:p>
-        </p:txBody>
-      </p:sp>
-      <p:sp>
-        <p:nvSpPr>
-          <p:cNvPr id="36" name="TextBox 35"/>
-          <p:cNvSpPr txBox="1"/>
-          <p:nvPr/>
-        </p:nvSpPr>
-        <p:spPr>
-          <a:xfrm>
-            <a:off x="9784444" y="2167128"/>
-            <a:ext cx="1995769" cy="685800"/>
-          </a:xfrm>
-          <a:prstGeom prst="rect">
-            <a:avLst/>
-          </a:prstGeom>
-          <a:noFill/>
-        </p:spPr>
-        <p:txBody>
-          <a:bodyPr wrap="square" anchor="t">
-            <a:spAutoFit/>
-          </a:bodyPr>
-          <a:lstStyle/>
-          <a:p>
-            <a:pPr algn="ctr">
-              <a:defRPr sz="1200" b="0">
-                <a:solidFill>
-                  <a:srgbClr val="B4BED2"/>
-                </a:solidFill>
-                <a:latin typeface="Microsoft YaHei"/>
-              </a:defRPr>
-            </a:pPr>
-            <a:r>
-              <a:t>落地千行百业，</a:t>
-            </a:r>
-            <a:br/>
-            <a:r>
-              <a:t>嵌入日常工作。</a:t>
-            </a:r>
-          </a:p>
-        </p:txBody>
-      </p:sp>
-      <p:sp>
-        <p:nvSpPr>
-          <p:cNvPr id="37" name="Oval 36"/>
-          <p:cNvSpPr/>
-          <p:nvPr/>
-        </p:nvSpPr>
-        <p:spPr>
-          <a:xfrm>
-            <a:off x="10453144" y="3017520"/>
-            <a:ext cx="658368" cy="658368"/>
-          </a:xfrm>
-          <a:prstGeom prst="ellipse">
-            <a:avLst/>
-          </a:prstGeom>
-          <a:solidFill>
-            <a:srgbClr val="3B82F6"/>
-          </a:solidFill>
-          <a:ln>
-            <a:noFill/>
-          </a:ln>
-        </p:spPr>
-        <p:style>
-          <a:lnRef idx="1">
-            <a:schemeClr val="accent1"/>
-          </a:lnRef>
-          <a:fillRef idx="3">
-            <a:schemeClr val="accent1"/>
-          </a:fillRef>
-          <a:effectRef idx="2">
-            <a:schemeClr val="accent1"/>
-          </a:effectRef>
-          <a:fontRef idx="minor">
-            <a:schemeClr val="lt1"/>
-          </a:fontRef>
-        </p:style>
-        <p:txBody>
-          <a:bodyPr rtlCol="0" anchor="ctr"/>
-          <a:lstStyle/>
-          <a:p>
-            <a:pPr algn="ctr"/>
-          </a:p>
-        </p:txBody>
-      </p:sp>
-      <p:sp>
-        <p:nvSpPr>
-          <p:cNvPr id="38" name="TextBox 37"/>
-          <p:cNvSpPr txBox="1"/>
-          <p:nvPr/>
-        </p:nvSpPr>
-        <p:spPr>
-          <a:xfrm>
-            <a:off x="10453144" y="3127248"/>
-            <a:ext cx="658368" cy="438912"/>
-          </a:xfrm>
-          <a:prstGeom prst="rect">
-            <a:avLst/>
-          </a:prstGeom>
-          <a:noFill/>
-        </p:spPr>
-        <p:txBody>
-          <a:bodyPr wrap="none" anchor="ctr">
-            <a:spAutoFit/>
-          </a:bodyPr>
-          <a:lstStyle/>
-          <a:p>
-            <a:pPr algn="ctr">
-              <a:defRPr sz="2200" b="1">
-                <a:solidFill>
-                  <a:srgbClr val="FFFFFF"/>
-                </a:solidFill>
-                <a:latin typeface="Microsoft YaHei"/>
-              </a:defRPr>
-            </a:pPr>
-            <a:r>
-              <a:t>用</a:t>
-            </a:r>
-          </a:p>
-        </p:txBody>
-      </p:sp>
-      <p:sp>
-        <p:nvSpPr>
-          <p:cNvPr id="39" name="Rounded Rectangle 38"/>
-          <p:cNvSpPr/>
-          <p:nvPr/>
-        </p:nvSpPr>
-        <p:spPr>
-          <a:xfrm>
-            <a:off x="9830164" y="3840480"/>
-            <a:ext cx="1904329" cy="1508760"/>
-          </a:xfrm>
-          <a:prstGeom prst="roundRect">
-            <a:avLst/>
-          </a:prstGeom>
-          <a:solidFill>
-            <a:srgbClr val="162844"/>
-          </a:solidFill>
-          <a:ln w="9525">
-            <a:solidFill>
-              <a:srgbClr val="2D4B78"/>
-            </a:solidFill>
-          </a:ln>
-        </p:spPr>
-        <p:style>
-          <a:lnRef idx="1">
-            <a:schemeClr val="accent1"/>
-          </a:lnRef>
-          <a:fillRef idx="3">
-            <a:schemeClr val="accent1"/>
-          </a:fillRef>
-          <a:effectRef idx="2">
-            <a:schemeClr val="accent1"/>
-          </a:effectRef>
-          <a:fontRef idx="minor">
-            <a:schemeClr val="lt1"/>
-          </a:fontRef>
-        </p:style>
-        <p:txBody>
-          <a:bodyPr rtlCol="0" anchor="ctr"/>
-          <a:lstStyle/>
-          <a:p>
-            <a:pPr algn="ctr"/>
-          </a:p>
-        </p:txBody>
-      </p:sp>
-      <p:sp>
-        <p:nvSpPr>
-          <p:cNvPr id="40" name="TextBox 39"/>
-          <p:cNvSpPr txBox="1"/>
-          <p:nvPr/>
-        </p:nvSpPr>
-        <p:spPr>
-          <a:xfrm>
-            <a:off x="9830164" y="4343400"/>
-            <a:ext cx="1904329" cy="457200"/>
-          </a:xfrm>
-          <a:prstGeom prst="rect">
-            <a:avLst/>
-          </a:prstGeom>
-          <a:noFill/>
-        </p:spPr>
-        <p:txBody>
-          <a:bodyPr wrap="square" anchor="t">
-            <a:spAutoFit/>
-          </a:bodyPr>
-          <a:lstStyle/>
-          <a:p>
-            <a:pPr algn="ctr">
-              <a:defRPr sz="1000" b="0">
-                <a:solidFill>
-                  <a:srgbClr val="6482AA"/>
-                </a:solidFill>
-                <a:latin typeface="Microsoft YaHei"/>
-              </a:defRPr>
-            </a:pPr>
-            <a:r>
-              <a:t>← 可替换图片</a:t>
-            </a:r>
-          </a:p>
-        </p:txBody>
-      </p:sp>
-      <p:sp>
-        <p:nvSpPr>
-          <p:cNvPr id="41" name="Rectangle 40"/>
-          <p:cNvSpPr/>
-          <p:nvPr/>
-        </p:nvSpPr>
-        <p:spPr>
-          <a:xfrm>
-            <a:off x="0" y="5806440"/>
-            <a:ext cx="12191695" cy="960120"/>
-          </a:xfrm>
-          <a:prstGeom prst="rect">
-            <a:avLst/>
-          </a:prstGeom>
-          <a:solidFill>
-            <a:srgbClr val="12233C"/>
-          </a:solidFill>
-          <a:ln>
-            <a:noFill/>
-          </a:ln>
-        </p:spPr>
-        <p:style>
-          <a:lnRef idx="1">
-            <a:schemeClr val="accent1"/>
-          </a:lnRef>
-          <a:fillRef idx="3">
-            <a:schemeClr val="accent1"/>
-          </a:fillRef>
-          <a:effectRef idx="2">
-            <a:schemeClr val="accent1"/>
-          </a:effectRef>
-          <a:fontRef idx="minor">
-            <a:schemeClr val="lt1"/>
-          </a:fontRef>
-        </p:style>
-        <p:txBody>
-          <a:bodyPr rtlCol="0" anchor="ctr"/>
-          <a:lstStyle/>
-          <a:p>
-            <a:pPr algn="ctr"/>
-          </a:p>
-        </p:txBody>
-      </p:sp>
-      <p:sp>
-        <p:nvSpPr>
-          <p:cNvPr id="42" name="TextBox 41"/>
-          <p:cNvSpPr txBox="1"/>
-          <p:nvPr/>
-        </p:nvSpPr>
-        <p:spPr>
-          <a:xfrm>
-            <a:off x="411480" y="6062472"/>
-            <a:ext cx="6583680" cy="502920"/>
-          </a:xfrm>
-          <a:prstGeom prst="rect">
-            <a:avLst/>
-          </a:prstGeom>
-          <a:noFill/>
-        </p:spPr>
-        <p:txBody>
-          <a:bodyPr wrap="none" anchor="ctr">
-            <a:spAutoFit/>
-          </a:bodyPr>
-          <a:lstStyle/>
-          <a:p>
-            <a:r>
-              <a:rPr sz="1500">
-                <a:solidFill>
-                  <a:srgbClr val="FFFFFF"/>
-                </a:solidFill>
-                <a:latin typeface="Microsoft YaHei"/>
-              </a:rPr>
-              <a:t>同一技术，不同层级。</a:t>
-            </a:r>
-            <a:r>
-              <a:rPr sz="1500" b="1">
-                <a:solidFill>
-                  <a:srgbClr val="F5C518"/>
-                </a:solidFill>
-                <a:latin typeface="Microsoft YaHei"/>
-              </a:rPr>
-              <a:t>看懂产业链，才能抓住价值。</a:t>
-            </a:r>
-          </a:p>
-        </p:txBody>
-      </p:sp>
-      <p:sp>
-        <p:nvSpPr>
-          <p:cNvPr id="43" name="Oval 42"/>
-          <p:cNvSpPr/>
-          <p:nvPr/>
-        </p:nvSpPr>
-        <p:spPr>
-          <a:xfrm>
-            <a:off x="7406640" y="5971032"/>
-            <a:ext cx="384048" cy="384048"/>
-          </a:xfrm>
-          <a:prstGeom prst="ellipse">
-            <a:avLst/>
-          </a:prstGeom>
-          <a:solidFill>
-            <a:srgbClr val="1E375A"/>
-          </a:solidFill>
-          <a:ln w="12700">
-            <a:solidFill>
-              <a:srgbClr val="3B82F6"/>
-            </a:solidFill>
-          </a:ln>
-        </p:spPr>
-        <p:style>
-          <a:lnRef idx="1">
-            <a:schemeClr val="accent1"/>
-          </a:lnRef>
-          <a:fillRef idx="3">
-            <a:schemeClr val="accent1"/>
-          </a:fillRef>
-          <a:effectRef idx="2">
-            <a:schemeClr val="accent1"/>
-          </a:effectRef>
-          <a:fontRef idx="minor">
-            <a:schemeClr val="lt1"/>
-          </a:fontRef>
-        </p:style>
-        <p:txBody>
-          <a:bodyPr rtlCol="0" anchor="ctr"/>
-          <a:lstStyle/>
-          <a:p>
-            <a:pPr algn="ctr"/>
-          </a:p>
-        </p:txBody>
-      </p:sp>
-      <p:sp>
-        <p:nvSpPr>
-          <p:cNvPr id="44" name="TextBox 43"/>
-          <p:cNvSpPr txBox="1"/>
-          <p:nvPr/>
-        </p:nvSpPr>
-        <p:spPr>
-          <a:xfrm>
-            <a:off x="7360920" y="6409944"/>
-            <a:ext cx="1234440" cy="320040"/>
-          </a:xfrm>
-          <a:prstGeom prst="rect">
-            <a:avLst/>
-          </a:prstGeom>
-          <a:noFill/>
-        </p:spPr>
-        <p:txBody>
-          <a:bodyPr wrap="square" anchor="t">
-            <a:spAutoFit/>
-          </a:bodyPr>
-          <a:lstStyle/>
-          <a:p>
-            <a:pPr algn="ctr">
-              <a:defRPr sz="1100" b="0">
-                <a:solidFill>
-                  <a:srgbClr val="FFFFFF"/>
-                </a:solidFill>
-                <a:latin typeface="Microsoft YaHei"/>
-              </a:defRPr>
-            </a:pPr>
-            <a:r>
-              <a:t>资本开支</a:t>
-            </a:r>
-          </a:p>
-        </p:txBody>
-      </p:sp>
-      <p:sp>
-        <p:nvSpPr>
-          <p:cNvPr id="45" name="Oval 44"/>
-          <p:cNvSpPr/>
-          <p:nvPr/>
-        </p:nvSpPr>
-        <p:spPr>
-          <a:xfrm>
-            <a:off x="8869680" y="5971032"/>
-            <a:ext cx="384048" cy="384048"/>
-          </a:xfrm>
-          <a:prstGeom prst="ellipse">
-            <a:avLst/>
-          </a:prstGeom>
-          <a:solidFill>
-            <a:srgbClr val="1E375A"/>
-          </a:solidFill>
-          <a:ln w="12700">
-            <a:solidFill>
-              <a:srgbClr val="3B82F6"/>
-            </a:solidFill>
-          </a:ln>
-        </p:spPr>
-        <p:style>
-          <a:lnRef idx="1">
-            <a:schemeClr val="accent1"/>
-          </a:lnRef>
-          <a:fillRef idx="3">
-            <a:schemeClr val="accent1"/>
-          </a:fillRef>
-          <a:effectRef idx="2">
-            <a:schemeClr val="accent1"/>
-          </a:effectRef>
-          <a:fontRef idx="minor">
-            <a:schemeClr val="lt1"/>
-          </a:fontRef>
-        </p:style>
-        <p:txBody>
-          <a:bodyPr rtlCol="0" anchor="ctr"/>
-          <a:lstStyle/>
-          <a:p>
-            <a:pPr algn="ctr"/>
-          </a:p>
-        </p:txBody>
-      </p:sp>
-      <p:sp>
-        <p:nvSpPr>
-          <p:cNvPr id="46" name="TextBox 45"/>
-          <p:cNvSpPr txBox="1"/>
-          <p:nvPr/>
-        </p:nvSpPr>
-        <p:spPr>
-          <a:xfrm>
-            <a:off x="8823960" y="6409944"/>
-            <a:ext cx="1234440" cy="320040"/>
-          </a:xfrm>
-          <a:prstGeom prst="rect">
-            <a:avLst/>
-          </a:prstGeom>
-          <a:noFill/>
-        </p:spPr>
-        <p:txBody>
-          <a:bodyPr wrap="square" anchor="t">
-            <a:spAutoFit/>
-          </a:bodyPr>
-          <a:lstStyle/>
-          <a:p>
-            <a:pPr algn="ctr">
-              <a:defRPr sz="1100" b="0">
-                <a:solidFill>
-                  <a:srgbClr val="FFFFFF"/>
-                </a:solidFill>
-                <a:latin typeface="Microsoft YaHei"/>
-              </a:defRPr>
-            </a:pPr>
-            <a:r>
-              <a:t>推理延迟</a:t>
-            </a:r>
-          </a:p>
-        </p:txBody>
-      </p:sp>
-      <p:sp>
-        <p:nvSpPr>
-          <p:cNvPr id="47" name="Oval 46"/>
-          <p:cNvSpPr/>
-          <p:nvPr/>
-        </p:nvSpPr>
-        <p:spPr>
-          <a:xfrm>
-            <a:off x="10332720" y="5971032"/>
-            <a:ext cx="384048" cy="384048"/>
-          </a:xfrm>
-          <a:prstGeom prst="ellipse">
-            <a:avLst/>
-          </a:prstGeom>
-          <a:solidFill>
-            <a:srgbClr val="1E375A"/>
-          </a:solidFill>
-          <a:ln w="12700">
-            <a:solidFill>
-              <a:srgbClr val="3B82F6"/>
-            </a:solidFill>
-          </a:ln>
-        </p:spPr>
-        <p:style>
-          <a:lnRef idx="1">
-            <a:schemeClr val="accent1"/>
-          </a:lnRef>
-          <a:fillRef idx="3">
-            <a:schemeClr val="accent1"/>
-          </a:fillRef>
-          <a:effectRef idx="2">
-            <a:schemeClr val="accent1"/>
-          </a:effectRef>
-          <a:fontRef idx="minor">
-            <a:schemeClr val="lt1"/>
-          </a:fontRef>
-        </p:style>
-        <p:txBody>
-          <a:bodyPr rtlCol="0" anchor="ctr"/>
-          <a:lstStyle/>
-          <a:p>
-            <a:pPr algn="ctr"/>
-          </a:p>
-        </p:txBody>
-      </p:sp>
-      <p:sp>
-        <p:nvSpPr>
-          <p:cNvPr id="48" name="TextBox 47"/>
-          <p:cNvSpPr txBox="1"/>
-          <p:nvPr/>
-        </p:nvSpPr>
-        <p:spPr>
-          <a:xfrm>
-            <a:off x="10287000" y="6409944"/>
-            <a:ext cx="1234440" cy="320040"/>
-          </a:xfrm>
-          <a:prstGeom prst="rect">
-            <a:avLst/>
-          </a:prstGeom>
-          <a:noFill/>
-        </p:spPr>
-        <p:txBody>
-          <a:bodyPr wrap="square" anchor="t">
-            <a:spAutoFit/>
-          </a:bodyPr>
-          <a:lstStyle/>
-          <a:p>
-            <a:pPr algn="ctr">
-              <a:defRPr sz="1100" b="0">
-                <a:solidFill>
-                  <a:srgbClr val="FFFFFF"/>
-                </a:solidFill>
-                <a:latin typeface="Microsoft YaHei"/>
-              </a:defRPr>
-            </a:pPr>
-            <a:r>
-              <a:t>单位经济</a:t>
-            </a:r>
-          </a:p>
-        </p:txBody>
-      </p:sp>
-      <p:sp>
-        <p:nvSpPr>
-          <p:cNvPr id="49" name="Oval 48"/>
-          <p:cNvSpPr/>
-          <p:nvPr/>
-        </p:nvSpPr>
-        <p:spPr>
-          <a:xfrm>
-            <a:off x="11795760" y="5971032"/>
-            <a:ext cx="384048" cy="384048"/>
-          </a:xfrm>
-          <a:prstGeom prst="ellipse">
-            <a:avLst/>
-          </a:prstGeom>
-          <a:solidFill>
-            <a:srgbClr val="1E375A"/>
-          </a:solidFill>
-          <a:ln w="12700">
-            <a:solidFill>
-              <a:srgbClr val="3B82F6"/>
-            </a:solidFill>
-          </a:ln>
-        </p:spPr>
-        <p:style>
-          <a:lnRef idx="1">
-            <a:schemeClr val="accent1"/>
-          </a:lnRef>
-          <a:fillRef idx="3">
-            <a:schemeClr val="accent1"/>
-          </a:fillRef>
-          <a:effectRef idx="2">
-            <a:schemeClr val="accent1"/>
-          </a:effectRef>
-          <a:fontRef idx="minor">
-            <a:schemeClr val="lt1"/>
-          </a:fontRef>
-        </p:style>
-        <p:txBody>
-          <a:bodyPr rtlCol="0" anchor="ctr"/>
-          <a:lstStyle/>
-          <a:p>
-            <a:pPr algn="ctr"/>
-          </a:p>
-        </p:txBody>
-      </p:sp>
-      <p:sp>
-        <p:nvSpPr>
-          <p:cNvPr id="50" name="TextBox 49"/>
-          <p:cNvSpPr txBox="1"/>
-          <p:nvPr/>
-        </p:nvSpPr>
-        <p:spPr>
-          <a:xfrm>
-            <a:off x="11750040" y="6409944"/>
-            <a:ext cx="1234440" cy="320040"/>
-          </a:xfrm>
-          <a:prstGeom prst="rect">
-            <a:avLst/>
-          </a:prstGeom>
-          <a:noFill/>
-        </p:spPr>
-        <p:txBody>
-          <a:bodyPr wrap="square" anchor="t">
-            <a:spAutoFit/>
-          </a:bodyPr>
-          <a:lstStyle/>
-          <a:p>
-            <a:pPr algn="ctr">
-              <a:defRPr sz="1100" b="0">
-                <a:solidFill>
-                  <a:srgbClr val="FFFFFF"/>
-                </a:solidFill>
-                <a:latin typeface="Microsoft YaHei"/>
-              </a:defRPr>
-            </a:pPr>
-            <a:r>
-              <a:t>产品契合</a:t>
-            </a:r>
-          </a:p>
-        </p:txBody>
-      </p:sp>
+        </p:spPr>
+      </p:pic>
     </p:spTree>
   </p:cSld>
   <p:clrMapOvr>
@@ -5125,14 +3176,57 @@
       </p:sp>
       <p:sp>
         <p:nvSpPr>
-          <p:cNvPr id="3" name="TextBox 2"/>
+          <p:cNvPr id="3" name="Rectangle 2"/>
+          <p:cNvSpPr/>
+          <p:nvPr/>
+        </p:nvSpPr>
+        <p:spPr>
+          <a:xfrm>
+            <a:off x="0" y="0"/>
+            <a:ext cx="12191695" cy="1417320"/>
+          </a:xfrm>
+          <a:prstGeom prst="rect">
+            <a:avLst/>
+          </a:prstGeom>
+          <a:solidFill>
+            <a:srgbClr val="12233C"/>
+          </a:solidFill>
+          <a:ln>
+            <a:noFill/>
+          </a:ln>
+        </p:spPr>
+        <p:style>
+          <a:lnRef idx="1">
+            <a:schemeClr val="accent1"/>
+          </a:lnRef>
+          <a:fillRef idx="3">
+            <a:schemeClr val="accent1"/>
+          </a:fillRef>
+          <a:effectRef idx="2">
+            <a:schemeClr val="accent1"/>
+          </a:effectRef>
+          <a:fontRef idx="minor">
+            <a:schemeClr val="lt1"/>
+          </a:fontRef>
+        </p:style>
+        <p:txBody>
+          <a:bodyPr rtlCol="0" anchor="ctr"/>
+          <a:lstStyle/>
+          <a:p>
+            <a:pPr algn="ctr"/>
+          </a:p>
+        </p:txBody>
+      </p:sp>
+      <p:sp>
+        <p:nvSpPr>
+          <p:cNvPr id="4" name="TextBox 3"/>
           <p:cNvSpPr txBox="1"/>
           <p:nvPr/>
         </p:nvSpPr>
         <p:spPr>
           <a:xfrm>
-            <a:off x="365760" y="182880"/>
-            <a:ext cx="9144000" cy="365760"/>
+            <a:off x="411480" y="256032"/>
+            <a:ext cx="10972800" cy="594360"/>
           </a:xfrm>
           <a:prstGeom prst="rect">
             <a:avLst/>
@@ -5146,7 +3240,43 @@
           <a:lstStyle/>
           <a:p>
             <a:pPr algn="l">
-              <a:defRPr sz="1400" b="0">
+              <a:defRPr sz="2800" b="1">
+                <a:solidFill>
+                  <a:srgbClr val="FFFFFF"/>
+                </a:solidFill>
+                <a:latin typeface="Microsoft YaHei"/>
+              </a:defRPr>
+            </a:pPr>
+            <a:r>
+              <a:t>做 AI 投资？最大的差异不是模型，而是产业链。</a:t>
+            </a:r>
+          </a:p>
+        </p:txBody>
+      </p:sp>
+      <p:sp>
+        <p:nvSpPr>
+          <p:cNvPr id="5" name="TextBox 4"/>
+          <p:cNvSpPr txBox="1"/>
+          <p:nvPr/>
+        </p:nvSpPr>
+        <p:spPr>
+          <a:xfrm>
+            <a:off x="411480" y="868680"/>
+            <a:ext cx="10972800" cy="365760"/>
+          </a:xfrm>
+          <a:prstGeom prst="rect">
+            <a:avLst/>
+          </a:prstGeom>
+          <a:noFill/>
+        </p:spPr>
+        <p:txBody>
+          <a:bodyPr wrap="square" anchor="t">
+            <a:spAutoFit/>
+          </a:bodyPr>
+          <a:lstStyle/>
+          <a:p>
+            <a:pPr algn="l">
+              <a:defRPr sz="1600" b="0">
                 <a:solidFill>
                   <a:srgbClr val="B4BED2"/>
                 </a:solidFill>
@@ -5154,14 +3284,214 @@
               </a:defRPr>
             </a:pPr>
             <a:r>
-              <a:t>参考图（第 1 页为可编辑版本）</a:t>
+              <a:t>五层结构，一条链条，价值从芯片流向应用。</a:t>
+            </a:r>
+          </a:p>
+        </p:txBody>
+      </p:sp>
+      <p:sp>
+        <p:nvSpPr>
+          <p:cNvPr id="6" name="Rounded Rectangle 5"/>
+          <p:cNvSpPr/>
+          <p:nvPr/>
+        </p:nvSpPr>
+        <p:spPr>
+          <a:xfrm>
+            <a:off x="320040" y="1600200"/>
+            <a:ext cx="2178649" cy="3977639"/>
+          </a:xfrm>
+          <a:prstGeom prst="roundRect">
+            <a:avLst/>
+          </a:prstGeom>
+          <a:solidFill>
+            <a:srgbClr val="0E1C32"/>
+          </a:solidFill>
+          <a:ln w="12700">
+            <a:solidFill>
+              <a:srgbClr val="1E375A"/>
+            </a:solidFill>
+          </a:ln>
+        </p:spPr>
+        <p:style>
+          <a:lnRef idx="1">
+            <a:schemeClr val="accent1"/>
+          </a:lnRef>
+          <a:fillRef idx="3">
+            <a:schemeClr val="accent1"/>
+          </a:fillRef>
+          <a:effectRef idx="2">
+            <a:schemeClr val="accent1"/>
+          </a:effectRef>
+          <a:fontRef idx="minor">
+            <a:schemeClr val="lt1"/>
+          </a:fontRef>
+        </p:style>
+        <p:txBody>
+          <a:bodyPr rtlCol="0" anchor="ctr"/>
+          <a:lstStyle/>
+          <a:p>
+            <a:pPr algn="ctr"/>
+          </a:p>
+        </p:txBody>
+      </p:sp>
+      <p:sp>
+        <p:nvSpPr>
+          <p:cNvPr id="7" name="TextBox 6"/>
+          <p:cNvSpPr txBox="1"/>
+          <p:nvPr/>
+        </p:nvSpPr>
+        <p:spPr>
+          <a:xfrm>
+            <a:off x="429768" y="1737360"/>
+            <a:ext cx="1959193" cy="411480"/>
+          </a:xfrm>
+          <a:prstGeom prst="rect">
+            <a:avLst/>
+          </a:prstGeom>
+          <a:noFill/>
+        </p:spPr>
+        <p:txBody>
+          <a:bodyPr wrap="square" anchor="t">
+            <a:spAutoFit/>
+          </a:bodyPr>
+          <a:lstStyle/>
+          <a:p>
+            <a:pPr algn="ctr">
+              <a:defRPr sz="2000" b="1">
+                <a:solidFill>
+                  <a:srgbClr val="FFFFFF"/>
+                </a:solidFill>
+                <a:latin typeface="Microsoft YaHei"/>
+              </a:defRPr>
+            </a:pPr>
+            <a:r>
+              <a:t>算力层</a:t>
+            </a:r>
+          </a:p>
+        </p:txBody>
+      </p:sp>
+      <p:sp>
+        <p:nvSpPr>
+          <p:cNvPr id="8" name="TextBox 7"/>
+          <p:cNvSpPr txBox="1"/>
+          <p:nvPr/>
+        </p:nvSpPr>
+        <p:spPr>
+          <a:xfrm>
+            <a:off x="411480" y="2167128"/>
+            <a:ext cx="1995769" cy="685800"/>
+          </a:xfrm>
+          <a:prstGeom prst="rect">
+            <a:avLst/>
+          </a:prstGeom>
+          <a:noFill/>
+        </p:spPr>
+        <p:txBody>
+          <a:bodyPr wrap="square" anchor="t">
+            <a:spAutoFit/>
+          </a:bodyPr>
+          <a:lstStyle/>
+          <a:p>
+            <a:pPr algn="ctr">
+              <a:defRPr sz="1200" b="0">
+                <a:solidFill>
+                  <a:srgbClr val="B4BED2"/>
+                </a:solidFill>
+                <a:latin typeface="Microsoft YaHei"/>
+              </a:defRPr>
+            </a:pPr>
+            <a:r>
+              <a:t>生于硅片，GPU 与 HBM</a:t>
+            </a:r>
+            <a:br/>
+            <a:r>
+              <a:t>驱动一切。</a:t>
+            </a:r>
+          </a:p>
+        </p:txBody>
+      </p:sp>
+      <p:sp>
+        <p:nvSpPr>
+          <p:cNvPr id="9" name="Oval 8"/>
+          <p:cNvSpPr/>
+          <p:nvPr/>
+        </p:nvSpPr>
+        <p:spPr>
+          <a:xfrm>
+            <a:off x="1080180" y="3017520"/>
+            <a:ext cx="658368" cy="658368"/>
+          </a:xfrm>
+          <a:prstGeom prst="ellipse">
+            <a:avLst/>
+          </a:prstGeom>
+          <a:solidFill>
+            <a:srgbClr val="3B82F6"/>
+          </a:solidFill>
+          <a:ln>
+            <a:noFill/>
+          </a:ln>
+        </p:spPr>
+        <p:style>
+          <a:lnRef idx="1">
+            <a:schemeClr val="accent1"/>
+          </a:lnRef>
+          <a:fillRef idx="3">
+            <a:schemeClr val="accent1"/>
+          </a:fillRef>
+          <a:effectRef idx="2">
+            <a:schemeClr val="accent1"/>
+          </a:effectRef>
+          <a:fontRef idx="minor">
+            <a:schemeClr val="lt1"/>
+          </a:fontRef>
+        </p:style>
+        <p:txBody>
+          <a:bodyPr rtlCol="0" anchor="ctr"/>
+          <a:lstStyle/>
+          <a:p>
+            <a:pPr algn="ctr"/>
+          </a:p>
+        </p:txBody>
+      </p:sp>
+      <p:sp>
+        <p:nvSpPr>
+          <p:cNvPr id="10" name="TextBox 9"/>
+          <p:cNvSpPr txBox="1"/>
+          <p:nvPr/>
+        </p:nvSpPr>
+        <p:spPr>
+          <a:xfrm>
+            <a:off x="1080180" y="3127248"/>
+            <a:ext cx="658368" cy="438912"/>
+          </a:xfrm>
+          <a:prstGeom prst="rect">
+            <a:avLst/>
+          </a:prstGeom>
+          <a:noFill/>
+        </p:spPr>
+        <p:txBody>
+          <a:bodyPr wrap="none" anchor="ctr">
+            <a:spAutoFit/>
+          </a:bodyPr>
+          <a:lstStyle/>
+          <a:p>
+            <a:pPr algn="ctr">
+              <a:defRPr sz="2200" b="1">
+                <a:solidFill>
+                  <a:srgbClr val="FFFFFF"/>
+                </a:solidFill>
+                <a:latin typeface="Microsoft YaHei"/>
+              </a:defRPr>
+            </a:pPr>
+            <a:r>
+              <a:t>芯</a:t>
             </a:r>
           </a:p>
         </p:txBody>
       </p:sp>
       <p:pic>
         <p:nvPicPr>
-          <p:cNvPr id="4" name="Picture 3" descr="ai-industry-chain-infographic-zh.png"/>
+          <p:cNvPr id="11" name="Picture 10" descr="col-1.png"/>
           <p:cNvPicPr>
             <a:picLocks noChangeAspect="1"/>
           </p:cNvPicPr>
@@ -5175,14 +3505,1320 @@
         </p:blipFill>
         <p:spPr>
           <a:xfrm>
-            <a:off x="182880" y="502920"/>
-            <a:ext cx="11795760" cy="7863840"/>
+            <a:off x="457200" y="3840480"/>
+            <a:ext cx="1904329" cy="1508760"/>
           </a:xfrm>
           <a:prstGeom prst="rect">
             <a:avLst/>
           </a:prstGeom>
         </p:spPr>
       </p:pic>
+      <p:sp>
+        <p:nvSpPr>
+          <p:cNvPr id="12" name="Rounded Rectangle 11"/>
+          <p:cNvSpPr/>
+          <p:nvPr/>
+        </p:nvSpPr>
+        <p:spPr>
+          <a:xfrm>
+            <a:off x="2663281" y="1600200"/>
+            <a:ext cx="2178649" cy="3977639"/>
+          </a:xfrm>
+          <a:prstGeom prst="roundRect">
+            <a:avLst/>
+          </a:prstGeom>
+          <a:solidFill>
+            <a:srgbClr val="0E1C32"/>
+          </a:solidFill>
+          <a:ln w="12700">
+            <a:solidFill>
+              <a:srgbClr val="1E375A"/>
+            </a:solidFill>
+          </a:ln>
+        </p:spPr>
+        <p:style>
+          <a:lnRef idx="1">
+            <a:schemeClr val="accent1"/>
+          </a:lnRef>
+          <a:fillRef idx="3">
+            <a:schemeClr val="accent1"/>
+          </a:fillRef>
+          <a:effectRef idx="2">
+            <a:schemeClr val="accent1"/>
+          </a:effectRef>
+          <a:fontRef idx="minor">
+            <a:schemeClr val="lt1"/>
+          </a:fontRef>
+        </p:style>
+        <p:txBody>
+          <a:bodyPr rtlCol="0" anchor="ctr"/>
+          <a:lstStyle/>
+          <a:p>
+            <a:pPr algn="ctr"/>
+          </a:p>
+        </p:txBody>
+      </p:sp>
+      <p:sp>
+        <p:nvSpPr>
+          <p:cNvPr id="13" name="TextBox 12"/>
+          <p:cNvSpPr txBox="1"/>
+          <p:nvPr/>
+        </p:nvSpPr>
+        <p:spPr>
+          <a:xfrm>
+            <a:off x="2773009" y="1737360"/>
+            <a:ext cx="1959193" cy="411480"/>
+          </a:xfrm>
+          <a:prstGeom prst="rect">
+            <a:avLst/>
+          </a:prstGeom>
+          <a:noFill/>
+        </p:spPr>
+        <p:txBody>
+          <a:bodyPr wrap="square" anchor="t">
+            <a:spAutoFit/>
+          </a:bodyPr>
+          <a:lstStyle/>
+          <a:p>
+            <a:pPr algn="ctr">
+              <a:defRPr sz="2000" b="1">
+                <a:solidFill>
+                  <a:srgbClr val="FFFFFF"/>
+                </a:solidFill>
+                <a:latin typeface="Microsoft YaHei"/>
+              </a:defRPr>
+            </a:pPr>
+            <a:r>
+              <a:t>基础设施层</a:t>
+            </a:r>
+          </a:p>
+        </p:txBody>
+      </p:sp>
+      <p:sp>
+        <p:nvSpPr>
+          <p:cNvPr id="14" name="TextBox 13"/>
+          <p:cNvSpPr txBox="1"/>
+          <p:nvPr/>
+        </p:nvSpPr>
+        <p:spPr>
+          <a:xfrm>
+            <a:off x="2754721" y="2167128"/>
+            <a:ext cx="1995769" cy="685800"/>
+          </a:xfrm>
+          <a:prstGeom prst="rect">
+            <a:avLst/>
+          </a:prstGeom>
+          <a:noFill/>
+        </p:spPr>
+        <p:txBody>
+          <a:bodyPr wrap="square" anchor="t">
+            <a:spAutoFit/>
+          </a:bodyPr>
+          <a:lstStyle/>
+          <a:p>
+            <a:pPr algn="ctr">
+              <a:defRPr sz="1200" b="0">
+                <a:solidFill>
+                  <a:srgbClr val="B4BED2"/>
+                </a:solidFill>
+                <a:latin typeface="Microsoft YaHei"/>
+              </a:defRPr>
+            </a:pPr>
+            <a:r>
+              <a:t>电力、液冷与万卡</a:t>
+            </a:r>
+            <a:br/>
+            <a:r>
+              <a:t>集群规模化。</a:t>
+            </a:r>
+          </a:p>
+        </p:txBody>
+      </p:sp>
+      <p:sp>
+        <p:nvSpPr>
+          <p:cNvPr id="15" name="Oval 14"/>
+          <p:cNvSpPr/>
+          <p:nvPr/>
+        </p:nvSpPr>
+        <p:spPr>
+          <a:xfrm>
+            <a:off x="3423421" y="3017520"/>
+            <a:ext cx="658368" cy="658368"/>
+          </a:xfrm>
+          <a:prstGeom prst="ellipse">
+            <a:avLst/>
+          </a:prstGeom>
+          <a:solidFill>
+            <a:srgbClr val="3B82F6"/>
+          </a:solidFill>
+          <a:ln>
+            <a:noFill/>
+          </a:ln>
+        </p:spPr>
+        <p:style>
+          <a:lnRef idx="1">
+            <a:schemeClr val="accent1"/>
+          </a:lnRef>
+          <a:fillRef idx="3">
+            <a:schemeClr val="accent1"/>
+          </a:fillRef>
+          <a:effectRef idx="2">
+            <a:schemeClr val="accent1"/>
+          </a:effectRef>
+          <a:fontRef idx="minor">
+            <a:schemeClr val="lt1"/>
+          </a:fontRef>
+        </p:style>
+        <p:txBody>
+          <a:bodyPr rtlCol="0" anchor="ctr"/>
+          <a:lstStyle/>
+          <a:p>
+            <a:pPr algn="ctr"/>
+          </a:p>
+        </p:txBody>
+      </p:sp>
+      <p:sp>
+        <p:nvSpPr>
+          <p:cNvPr id="16" name="TextBox 15"/>
+          <p:cNvSpPr txBox="1"/>
+          <p:nvPr/>
+        </p:nvSpPr>
+        <p:spPr>
+          <a:xfrm>
+            <a:off x="3423421" y="3127248"/>
+            <a:ext cx="658368" cy="438912"/>
+          </a:xfrm>
+          <a:prstGeom prst="rect">
+            <a:avLst/>
+          </a:prstGeom>
+          <a:noFill/>
+        </p:spPr>
+        <p:txBody>
+          <a:bodyPr wrap="none" anchor="ctr">
+            <a:spAutoFit/>
+          </a:bodyPr>
+          <a:lstStyle/>
+          <a:p>
+            <a:pPr algn="ctr">
+              <a:defRPr sz="2200" b="1">
+                <a:solidFill>
+                  <a:srgbClr val="FFFFFF"/>
+                </a:solidFill>
+                <a:latin typeface="Microsoft YaHei"/>
+              </a:defRPr>
+            </a:pPr>
+            <a:r>
+              <a:t>云</a:t>
+            </a:r>
+          </a:p>
+        </p:txBody>
+      </p:sp>
+      <p:pic>
+        <p:nvPicPr>
+          <p:cNvPr id="17" name="Picture 16" descr="col-2.png"/>
+          <p:cNvPicPr>
+            <a:picLocks noChangeAspect="1"/>
+          </p:cNvPicPr>
+          <p:nvPr/>
+        </p:nvPicPr>
+        <p:blipFill>
+          <a:blip r:embed="rId3"/>
+          <a:stretch>
+            <a:fillRect/>
+          </a:stretch>
+        </p:blipFill>
+        <p:spPr>
+          <a:xfrm>
+            <a:off x="2800441" y="3840480"/>
+            <a:ext cx="1904329" cy="1508760"/>
+          </a:xfrm>
+          <a:prstGeom prst="rect">
+            <a:avLst/>
+          </a:prstGeom>
+        </p:spPr>
+      </p:pic>
+      <p:sp>
+        <p:nvSpPr>
+          <p:cNvPr id="18" name="Rounded Rectangle 17"/>
+          <p:cNvSpPr/>
+          <p:nvPr/>
+        </p:nvSpPr>
+        <p:spPr>
+          <a:xfrm>
+            <a:off x="5006522" y="1600200"/>
+            <a:ext cx="2178649" cy="3977639"/>
+          </a:xfrm>
+          <a:prstGeom prst="roundRect">
+            <a:avLst/>
+          </a:prstGeom>
+          <a:solidFill>
+            <a:srgbClr val="0E1C32"/>
+          </a:solidFill>
+          <a:ln w="12700">
+            <a:solidFill>
+              <a:srgbClr val="1E375A"/>
+            </a:solidFill>
+          </a:ln>
+        </p:spPr>
+        <p:style>
+          <a:lnRef idx="1">
+            <a:schemeClr val="accent1"/>
+          </a:lnRef>
+          <a:fillRef idx="3">
+            <a:schemeClr val="accent1"/>
+          </a:fillRef>
+          <a:effectRef idx="2">
+            <a:schemeClr val="accent1"/>
+          </a:effectRef>
+          <a:fontRef idx="minor">
+            <a:schemeClr val="lt1"/>
+          </a:fontRef>
+        </p:style>
+        <p:txBody>
+          <a:bodyPr rtlCol="0" anchor="ctr"/>
+          <a:lstStyle/>
+          <a:p>
+            <a:pPr algn="ctr"/>
+          </a:p>
+        </p:txBody>
+      </p:sp>
+      <p:sp>
+        <p:nvSpPr>
+          <p:cNvPr id="19" name="TextBox 18"/>
+          <p:cNvSpPr txBox="1"/>
+          <p:nvPr/>
+        </p:nvSpPr>
+        <p:spPr>
+          <a:xfrm>
+            <a:off x="5116250" y="1737360"/>
+            <a:ext cx="1959193" cy="411480"/>
+          </a:xfrm>
+          <a:prstGeom prst="rect">
+            <a:avLst/>
+          </a:prstGeom>
+          <a:noFill/>
+        </p:spPr>
+        <p:txBody>
+          <a:bodyPr wrap="square" anchor="t">
+            <a:spAutoFit/>
+          </a:bodyPr>
+          <a:lstStyle/>
+          <a:p>
+            <a:pPr algn="ctr">
+              <a:defRPr sz="2000" b="1">
+                <a:solidFill>
+                  <a:srgbClr val="FFFFFF"/>
+                </a:solidFill>
+                <a:latin typeface="Microsoft YaHei"/>
+              </a:defRPr>
+            </a:pPr>
+            <a:r>
+              <a:t>模型层</a:t>
+            </a:r>
+          </a:p>
+        </p:txBody>
+      </p:sp>
+      <p:sp>
+        <p:nvSpPr>
+          <p:cNvPr id="20" name="TextBox 19"/>
+          <p:cNvSpPr txBox="1"/>
+          <p:nvPr/>
+        </p:nvSpPr>
+        <p:spPr>
+          <a:xfrm>
+            <a:off x="5097962" y="2167128"/>
+            <a:ext cx="1995769" cy="685800"/>
+          </a:xfrm>
+          <a:prstGeom prst="rect">
+            <a:avLst/>
+          </a:prstGeom>
+          <a:noFill/>
+        </p:spPr>
+        <p:txBody>
+          <a:bodyPr wrap="square" anchor="t">
+            <a:spAutoFit/>
+          </a:bodyPr>
+          <a:lstStyle/>
+          <a:p>
+            <a:pPr algn="ctr">
+              <a:defRPr sz="1200" b="0">
+                <a:solidFill>
+                  <a:srgbClr val="B4BED2"/>
+                </a:solidFill>
+                <a:latin typeface="Microsoft YaHei"/>
+              </a:defRPr>
+            </a:pPr>
+            <a:r>
+              <a:t>数据训练，算力炼成</a:t>
+            </a:r>
+            <a:br/>
+            <a:r>
+              <a:t>认知能力。</a:t>
+            </a:r>
+          </a:p>
+        </p:txBody>
+      </p:sp>
+      <p:sp>
+        <p:nvSpPr>
+          <p:cNvPr id="21" name="Oval 20"/>
+          <p:cNvSpPr/>
+          <p:nvPr/>
+        </p:nvSpPr>
+        <p:spPr>
+          <a:xfrm>
+            <a:off x="5766662" y="3017520"/>
+            <a:ext cx="658368" cy="658368"/>
+          </a:xfrm>
+          <a:prstGeom prst="ellipse">
+            <a:avLst/>
+          </a:prstGeom>
+          <a:solidFill>
+            <a:srgbClr val="3B82F6"/>
+          </a:solidFill>
+          <a:ln>
+            <a:noFill/>
+          </a:ln>
+        </p:spPr>
+        <p:style>
+          <a:lnRef idx="1">
+            <a:schemeClr val="accent1"/>
+          </a:lnRef>
+          <a:fillRef idx="3">
+            <a:schemeClr val="accent1"/>
+          </a:fillRef>
+          <a:effectRef idx="2">
+            <a:schemeClr val="accent1"/>
+          </a:effectRef>
+          <a:fontRef idx="minor">
+            <a:schemeClr val="lt1"/>
+          </a:fontRef>
+        </p:style>
+        <p:txBody>
+          <a:bodyPr rtlCol="0" anchor="ctr"/>
+          <a:lstStyle/>
+          <a:p>
+            <a:pPr algn="ctr"/>
+          </a:p>
+        </p:txBody>
+      </p:sp>
+      <p:sp>
+        <p:nvSpPr>
+          <p:cNvPr id="22" name="TextBox 21"/>
+          <p:cNvSpPr txBox="1"/>
+          <p:nvPr/>
+        </p:nvSpPr>
+        <p:spPr>
+          <a:xfrm>
+            <a:off x="5766662" y="3127248"/>
+            <a:ext cx="658368" cy="438912"/>
+          </a:xfrm>
+          <a:prstGeom prst="rect">
+            <a:avLst/>
+          </a:prstGeom>
+          <a:noFill/>
+        </p:spPr>
+        <p:txBody>
+          <a:bodyPr wrap="none" anchor="ctr">
+            <a:spAutoFit/>
+          </a:bodyPr>
+          <a:lstStyle/>
+          <a:p>
+            <a:pPr algn="ctr">
+              <a:defRPr sz="2200" b="1">
+                <a:solidFill>
+                  <a:srgbClr val="FFFFFF"/>
+                </a:solidFill>
+                <a:latin typeface="Microsoft YaHei"/>
+              </a:defRPr>
+            </a:pPr>
+            <a:r>
+              <a:t>脑</a:t>
+            </a:r>
+          </a:p>
+        </p:txBody>
+      </p:sp>
+      <p:pic>
+        <p:nvPicPr>
+          <p:cNvPr id="23" name="Picture 22" descr="col-3.png"/>
+          <p:cNvPicPr>
+            <a:picLocks noChangeAspect="1"/>
+          </p:cNvPicPr>
+          <p:nvPr/>
+        </p:nvPicPr>
+        <p:blipFill>
+          <a:blip r:embed="rId4"/>
+          <a:stretch>
+            <a:fillRect/>
+          </a:stretch>
+        </p:blipFill>
+        <p:spPr>
+          <a:xfrm>
+            <a:off x="5143682" y="3840480"/>
+            <a:ext cx="1904329" cy="1508760"/>
+          </a:xfrm>
+          <a:prstGeom prst="rect">
+            <a:avLst/>
+          </a:prstGeom>
+        </p:spPr>
+      </p:pic>
+      <p:sp>
+        <p:nvSpPr>
+          <p:cNvPr id="24" name="Rounded Rectangle 23"/>
+          <p:cNvSpPr/>
+          <p:nvPr/>
+        </p:nvSpPr>
+        <p:spPr>
+          <a:xfrm>
+            <a:off x="7349763" y="1600200"/>
+            <a:ext cx="2178649" cy="3977639"/>
+          </a:xfrm>
+          <a:prstGeom prst="roundRect">
+            <a:avLst/>
+          </a:prstGeom>
+          <a:solidFill>
+            <a:srgbClr val="0E1C32"/>
+          </a:solidFill>
+          <a:ln w="12700">
+            <a:solidFill>
+              <a:srgbClr val="1E375A"/>
+            </a:solidFill>
+          </a:ln>
+        </p:spPr>
+        <p:style>
+          <a:lnRef idx="1">
+            <a:schemeClr val="accent1"/>
+          </a:lnRef>
+          <a:fillRef idx="3">
+            <a:schemeClr val="accent1"/>
+          </a:fillRef>
+          <a:effectRef idx="2">
+            <a:schemeClr val="accent1"/>
+          </a:effectRef>
+          <a:fontRef idx="minor">
+            <a:schemeClr val="lt1"/>
+          </a:fontRef>
+        </p:style>
+        <p:txBody>
+          <a:bodyPr rtlCol="0" anchor="ctr"/>
+          <a:lstStyle/>
+          <a:p>
+            <a:pPr algn="ctr"/>
+          </a:p>
+        </p:txBody>
+      </p:sp>
+      <p:sp>
+        <p:nvSpPr>
+          <p:cNvPr id="25" name="TextBox 24"/>
+          <p:cNvSpPr txBox="1"/>
+          <p:nvPr/>
+        </p:nvSpPr>
+        <p:spPr>
+          <a:xfrm>
+            <a:off x="7459491" y="1737360"/>
+            <a:ext cx="1959193" cy="411480"/>
+          </a:xfrm>
+          <a:prstGeom prst="rect">
+            <a:avLst/>
+          </a:prstGeom>
+          <a:noFill/>
+        </p:spPr>
+        <p:txBody>
+          <a:bodyPr wrap="square" anchor="t">
+            <a:spAutoFit/>
+          </a:bodyPr>
+          <a:lstStyle/>
+          <a:p>
+            <a:pPr algn="ctr">
+              <a:defRPr sz="2000" b="1">
+                <a:solidFill>
+                  <a:srgbClr val="FFFFFF"/>
+                </a:solidFill>
+                <a:latin typeface="Microsoft YaHei"/>
+              </a:defRPr>
+            </a:pPr>
+            <a:r>
+              <a:t>智能体层</a:t>
+            </a:r>
+          </a:p>
+        </p:txBody>
+      </p:sp>
+      <p:sp>
+        <p:nvSpPr>
+          <p:cNvPr id="26" name="TextBox 25"/>
+          <p:cNvSpPr txBox="1"/>
+          <p:nvPr/>
+        </p:nvSpPr>
+        <p:spPr>
+          <a:xfrm>
+            <a:off x="7441203" y="2167128"/>
+            <a:ext cx="1995769" cy="685800"/>
+          </a:xfrm>
+          <a:prstGeom prst="rect">
+            <a:avLst/>
+          </a:prstGeom>
+          <a:noFill/>
+        </p:spPr>
+        <p:txBody>
+          <a:bodyPr wrap="square" anchor="t">
+            <a:spAutoFit/>
+          </a:bodyPr>
+          <a:lstStyle/>
+          <a:p>
+            <a:pPr algn="ctr">
+              <a:defRPr sz="1200" b="0">
+                <a:solidFill>
+                  <a:srgbClr val="B4BED2"/>
+                </a:solidFill>
+                <a:latin typeface="Microsoft YaHei"/>
+              </a:defRPr>
+            </a:pPr>
+            <a:r>
+              <a:t>工具编排，自主规划</a:t>
+            </a:r>
+            <a:br/>
+            <a:r>
+              <a:t>与闭环执行。</a:t>
+            </a:r>
+          </a:p>
+        </p:txBody>
+      </p:sp>
+      <p:sp>
+        <p:nvSpPr>
+          <p:cNvPr id="27" name="Oval 26"/>
+          <p:cNvSpPr/>
+          <p:nvPr/>
+        </p:nvSpPr>
+        <p:spPr>
+          <a:xfrm>
+            <a:off x="8109903" y="3017520"/>
+            <a:ext cx="658368" cy="658368"/>
+          </a:xfrm>
+          <a:prstGeom prst="ellipse">
+            <a:avLst/>
+          </a:prstGeom>
+          <a:solidFill>
+            <a:srgbClr val="3B82F6"/>
+          </a:solidFill>
+          <a:ln>
+            <a:noFill/>
+          </a:ln>
+        </p:spPr>
+        <p:style>
+          <a:lnRef idx="1">
+            <a:schemeClr val="accent1"/>
+          </a:lnRef>
+          <a:fillRef idx="3">
+            <a:schemeClr val="accent1"/>
+          </a:fillRef>
+          <a:effectRef idx="2">
+            <a:schemeClr val="accent1"/>
+          </a:effectRef>
+          <a:fontRef idx="minor">
+            <a:schemeClr val="lt1"/>
+          </a:fontRef>
+        </p:style>
+        <p:txBody>
+          <a:bodyPr rtlCol="0" anchor="ctr"/>
+          <a:lstStyle/>
+          <a:p>
+            <a:pPr algn="ctr"/>
+          </a:p>
+        </p:txBody>
+      </p:sp>
+      <p:sp>
+        <p:nvSpPr>
+          <p:cNvPr id="28" name="TextBox 27"/>
+          <p:cNvSpPr txBox="1"/>
+          <p:nvPr/>
+        </p:nvSpPr>
+        <p:spPr>
+          <a:xfrm>
+            <a:off x="8109903" y="3127248"/>
+            <a:ext cx="658368" cy="438912"/>
+          </a:xfrm>
+          <a:prstGeom prst="rect">
+            <a:avLst/>
+          </a:prstGeom>
+          <a:noFill/>
+        </p:spPr>
+        <p:txBody>
+          <a:bodyPr wrap="none" anchor="ctr">
+            <a:spAutoFit/>
+          </a:bodyPr>
+          <a:lstStyle/>
+          <a:p>
+            <a:pPr algn="ctr">
+              <a:defRPr sz="2200" b="1">
+                <a:solidFill>
+                  <a:srgbClr val="FFFFFF"/>
+                </a:solidFill>
+                <a:latin typeface="Microsoft YaHei"/>
+              </a:defRPr>
+            </a:pPr>
+            <a:r>
+              <a:t>链</a:t>
+            </a:r>
+          </a:p>
+        </p:txBody>
+      </p:sp>
+      <p:pic>
+        <p:nvPicPr>
+          <p:cNvPr id="29" name="Picture 28" descr="col-4.png"/>
+          <p:cNvPicPr>
+            <a:picLocks noChangeAspect="1"/>
+          </p:cNvPicPr>
+          <p:nvPr/>
+        </p:nvPicPr>
+        <p:blipFill>
+          <a:blip r:embed="rId5"/>
+          <a:stretch>
+            <a:fillRect/>
+          </a:stretch>
+        </p:blipFill>
+        <p:spPr>
+          <a:xfrm>
+            <a:off x="7486923" y="3840480"/>
+            <a:ext cx="1904329" cy="1508760"/>
+          </a:xfrm>
+          <a:prstGeom prst="rect">
+            <a:avLst/>
+          </a:prstGeom>
+        </p:spPr>
+      </p:pic>
+      <p:sp>
+        <p:nvSpPr>
+          <p:cNvPr id="30" name="Rounded Rectangle 29"/>
+          <p:cNvSpPr/>
+          <p:nvPr/>
+        </p:nvSpPr>
+        <p:spPr>
+          <a:xfrm>
+            <a:off x="9693004" y="1600200"/>
+            <a:ext cx="2178649" cy="3977639"/>
+          </a:xfrm>
+          <a:prstGeom prst="roundRect">
+            <a:avLst/>
+          </a:prstGeom>
+          <a:solidFill>
+            <a:srgbClr val="0E1C32"/>
+          </a:solidFill>
+          <a:ln w="12700">
+            <a:solidFill>
+              <a:srgbClr val="1E375A"/>
+            </a:solidFill>
+          </a:ln>
+        </p:spPr>
+        <p:style>
+          <a:lnRef idx="1">
+            <a:schemeClr val="accent1"/>
+          </a:lnRef>
+          <a:fillRef idx="3">
+            <a:schemeClr val="accent1"/>
+          </a:fillRef>
+          <a:effectRef idx="2">
+            <a:schemeClr val="accent1"/>
+          </a:effectRef>
+          <a:fontRef idx="minor">
+            <a:schemeClr val="lt1"/>
+          </a:fontRef>
+        </p:style>
+        <p:txBody>
+          <a:bodyPr rtlCol="0" anchor="ctr"/>
+          <a:lstStyle/>
+          <a:p>
+            <a:pPr algn="ctr"/>
+          </a:p>
+        </p:txBody>
+      </p:sp>
+      <p:sp>
+        <p:nvSpPr>
+          <p:cNvPr id="31" name="TextBox 30"/>
+          <p:cNvSpPr txBox="1"/>
+          <p:nvPr/>
+        </p:nvSpPr>
+        <p:spPr>
+          <a:xfrm>
+            <a:off x="9802732" y="1737360"/>
+            <a:ext cx="1959193" cy="411480"/>
+          </a:xfrm>
+          <a:prstGeom prst="rect">
+            <a:avLst/>
+          </a:prstGeom>
+          <a:noFill/>
+        </p:spPr>
+        <p:txBody>
+          <a:bodyPr wrap="square" anchor="t">
+            <a:spAutoFit/>
+          </a:bodyPr>
+          <a:lstStyle/>
+          <a:p>
+            <a:pPr algn="ctr">
+              <a:defRPr sz="2000" b="1">
+                <a:solidFill>
+                  <a:srgbClr val="FFFFFF"/>
+                </a:solidFill>
+                <a:latin typeface="Microsoft YaHei"/>
+              </a:defRPr>
+            </a:pPr>
+            <a:r>
+              <a:t>应用层</a:t>
+            </a:r>
+          </a:p>
+        </p:txBody>
+      </p:sp>
+      <p:sp>
+        <p:nvSpPr>
+          <p:cNvPr id="32" name="TextBox 31"/>
+          <p:cNvSpPr txBox="1"/>
+          <p:nvPr/>
+        </p:nvSpPr>
+        <p:spPr>
+          <a:xfrm>
+            <a:off x="9784444" y="2167128"/>
+            <a:ext cx="1995769" cy="685800"/>
+          </a:xfrm>
+          <a:prstGeom prst="rect">
+            <a:avLst/>
+          </a:prstGeom>
+          <a:noFill/>
+        </p:spPr>
+        <p:txBody>
+          <a:bodyPr wrap="square" anchor="t">
+            <a:spAutoFit/>
+          </a:bodyPr>
+          <a:lstStyle/>
+          <a:p>
+            <a:pPr algn="ctr">
+              <a:defRPr sz="1200" b="0">
+                <a:solidFill>
+                  <a:srgbClr val="B4BED2"/>
+                </a:solidFill>
+                <a:latin typeface="Microsoft YaHei"/>
+              </a:defRPr>
+            </a:pPr>
+            <a:r>
+              <a:t>落地千行百业，</a:t>
+            </a:r>
+            <a:br/>
+            <a:r>
+              <a:t>嵌入日常工作。</a:t>
+            </a:r>
+          </a:p>
+        </p:txBody>
+      </p:sp>
+      <p:sp>
+        <p:nvSpPr>
+          <p:cNvPr id="33" name="Oval 32"/>
+          <p:cNvSpPr/>
+          <p:nvPr/>
+        </p:nvSpPr>
+        <p:spPr>
+          <a:xfrm>
+            <a:off x="10453144" y="3017520"/>
+            <a:ext cx="658368" cy="658368"/>
+          </a:xfrm>
+          <a:prstGeom prst="ellipse">
+            <a:avLst/>
+          </a:prstGeom>
+          <a:solidFill>
+            <a:srgbClr val="3B82F6"/>
+          </a:solidFill>
+          <a:ln>
+            <a:noFill/>
+          </a:ln>
+        </p:spPr>
+        <p:style>
+          <a:lnRef idx="1">
+            <a:schemeClr val="accent1"/>
+          </a:lnRef>
+          <a:fillRef idx="3">
+            <a:schemeClr val="accent1"/>
+          </a:fillRef>
+          <a:effectRef idx="2">
+            <a:schemeClr val="accent1"/>
+          </a:effectRef>
+          <a:fontRef idx="minor">
+            <a:schemeClr val="lt1"/>
+          </a:fontRef>
+        </p:style>
+        <p:txBody>
+          <a:bodyPr rtlCol="0" anchor="ctr"/>
+          <a:lstStyle/>
+          <a:p>
+            <a:pPr algn="ctr"/>
+          </a:p>
+        </p:txBody>
+      </p:sp>
+      <p:sp>
+        <p:nvSpPr>
+          <p:cNvPr id="34" name="TextBox 33"/>
+          <p:cNvSpPr txBox="1"/>
+          <p:nvPr/>
+        </p:nvSpPr>
+        <p:spPr>
+          <a:xfrm>
+            <a:off x="10453144" y="3127248"/>
+            <a:ext cx="658368" cy="438912"/>
+          </a:xfrm>
+          <a:prstGeom prst="rect">
+            <a:avLst/>
+          </a:prstGeom>
+          <a:noFill/>
+        </p:spPr>
+        <p:txBody>
+          <a:bodyPr wrap="none" anchor="ctr">
+            <a:spAutoFit/>
+          </a:bodyPr>
+          <a:lstStyle/>
+          <a:p>
+            <a:pPr algn="ctr">
+              <a:defRPr sz="2200" b="1">
+                <a:solidFill>
+                  <a:srgbClr val="FFFFFF"/>
+                </a:solidFill>
+                <a:latin typeface="Microsoft YaHei"/>
+              </a:defRPr>
+            </a:pPr>
+            <a:r>
+              <a:t>用</a:t>
+            </a:r>
+          </a:p>
+        </p:txBody>
+      </p:sp>
+      <p:pic>
+        <p:nvPicPr>
+          <p:cNvPr id="35" name="Picture 34" descr="col-5.png"/>
+          <p:cNvPicPr>
+            <a:picLocks noChangeAspect="1"/>
+          </p:cNvPicPr>
+          <p:nvPr/>
+        </p:nvPicPr>
+        <p:blipFill>
+          <a:blip r:embed="rId6"/>
+          <a:stretch>
+            <a:fillRect/>
+          </a:stretch>
+        </p:blipFill>
+        <p:spPr>
+          <a:xfrm>
+            <a:off x="9830164" y="3840480"/>
+            <a:ext cx="1904329" cy="1508760"/>
+          </a:xfrm>
+          <a:prstGeom prst="rect">
+            <a:avLst/>
+          </a:prstGeom>
+        </p:spPr>
+      </p:pic>
+      <p:sp>
+        <p:nvSpPr>
+          <p:cNvPr id="36" name="Rectangle 35"/>
+          <p:cNvSpPr/>
+          <p:nvPr/>
+        </p:nvSpPr>
+        <p:spPr>
+          <a:xfrm>
+            <a:off x="0" y="5806440"/>
+            <a:ext cx="12191695" cy="960120"/>
+          </a:xfrm>
+          <a:prstGeom prst="rect">
+            <a:avLst/>
+          </a:prstGeom>
+          <a:solidFill>
+            <a:srgbClr val="12233C"/>
+          </a:solidFill>
+          <a:ln>
+            <a:noFill/>
+          </a:ln>
+        </p:spPr>
+        <p:style>
+          <a:lnRef idx="1">
+            <a:schemeClr val="accent1"/>
+          </a:lnRef>
+          <a:fillRef idx="3">
+            <a:schemeClr val="accent1"/>
+          </a:fillRef>
+          <a:effectRef idx="2">
+            <a:schemeClr val="accent1"/>
+          </a:effectRef>
+          <a:fontRef idx="minor">
+            <a:schemeClr val="lt1"/>
+          </a:fontRef>
+        </p:style>
+        <p:txBody>
+          <a:bodyPr rtlCol="0" anchor="ctr"/>
+          <a:lstStyle/>
+          <a:p>
+            <a:pPr algn="ctr"/>
+          </a:p>
+        </p:txBody>
+      </p:sp>
+      <p:sp>
+        <p:nvSpPr>
+          <p:cNvPr id="37" name="TextBox 36"/>
+          <p:cNvSpPr txBox="1"/>
+          <p:nvPr/>
+        </p:nvSpPr>
+        <p:spPr>
+          <a:xfrm>
+            <a:off x="411480" y="6062472"/>
+            <a:ext cx="6583680" cy="502920"/>
+          </a:xfrm>
+          <a:prstGeom prst="rect">
+            <a:avLst/>
+          </a:prstGeom>
+          <a:noFill/>
+        </p:spPr>
+        <p:txBody>
+          <a:bodyPr wrap="none" anchor="ctr">
+            <a:spAutoFit/>
+          </a:bodyPr>
+          <a:lstStyle/>
+          <a:p>
+            <a:r>
+              <a:rPr sz="1500">
+                <a:solidFill>
+                  <a:srgbClr val="FFFFFF"/>
+                </a:solidFill>
+                <a:latin typeface="Microsoft YaHei"/>
+              </a:rPr>
+              <a:t>同一技术，不同层级。</a:t>
+            </a:r>
+            <a:r>
+              <a:rPr sz="1500" b="1">
+                <a:solidFill>
+                  <a:srgbClr val="F5C518"/>
+                </a:solidFill>
+                <a:latin typeface="Microsoft YaHei"/>
+              </a:rPr>
+              <a:t>看懂产业链，才能抓住价值。</a:t>
+            </a:r>
+          </a:p>
+        </p:txBody>
+      </p:sp>
+      <p:sp>
+        <p:nvSpPr>
+          <p:cNvPr id="38" name="Oval 37"/>
+          <p:cNvSpPr/>
+          <p:nvPr/>
+        </p:nvSpPr>
+        <p:spPr>
+          <a:xfrm>
+            <a:off x="7406640" y="5971032"/>
+            <a:ext cx="384048" cy="384048"/>
+          </a:xfrm>
+          <a:prstGeom prst="ellipse">
+            <a:avLst/>
+          </a:prstGeom>
+          <a:solidFill>
+            <a:srgbClr val="1E375A"/>
+          </a:solidFill>
+          <a:ln w="12700">
+            <a:solidFill>
+              <a:srgbClr val="3B82F6"/>
+            </a:solidFill>
+          </a:ln>
+        </p:spPr>
+        <p:style>
+          <a:lnRef idx="1">
+            <a:schemeClr val="accent1"/>
+          </a:lnRef>
+          <a:fillRef idx="3">
+            <a:schemeClr val="accent1"/>
+          </a:fillRef>
+          <a:effectRef idx="2">
+            <a:schemeClr val="accent1"/>
+          </a:effectRef>
+          <a:fontRef idx="minor">
+            <a:schemeClr val="lt1"/>
+          </a:fontRef>
+        </p:style>
+        <p:txBody>
+          <a:bodyPr rtlCol="0" anchor="ctr"/>
+          <a:lstStyle/>
+          <a:p>
+            <a:pPr algn="ctr"/>
+          </a:p>
+        </p:txBody>
+      </p:sp>
+      <p:sp>
+        <p:nvSpPr>
+          <p:cNvPr id="39" name="TextBox 38"/>
+          <p:cNvSpPr txBox="1"/>
+          <p:nvPr/>
+        </p:nvSpPr>
+        <p:spPr>
+          <a:xfrm>
+            <a:off x="7360920" y="6409944"/>
+            <a:ext cx="1234440" cy="320040"/>
+          </a:xfrm>
+          <a:prstGeom prst="rect">
+            <a:avLst/>
+          </a:prstGeom>
+          <a:noFill/>
+        </p:spPr>
+        <p:txBody>
+          <a:bodyPr wrap="square" anchor="t">
+            <a:spAutoFit/>
+          </a:bodyPr>
+          <a:lstStyle/>
+          <a:p>
+            <a:pPr algn="ctr">
+              <a:defRPr sz="1100" b="0">
+                <a:solidFill>
+                  <a:srgbClr val="FFFFFF"/>
+                </a:solidFill>
+                <a:latin typeface="Microsoft YaHei"/>
+              </a:defRPr>
+            </a:pPr>
+            <a:r>
+              <a:t>资本开支</a:t>
+            </a:r>
+          </a:p>
+        </p:txBody>
+      </p:sp>
+      <p:sp>
+        <p:nvSpPr>
+          <p:cNvPr id="40" name="Oval 39"/>
+          <p:cNvSpPr/>
+          <p:nvPr/>
+        </p:nvSpPr>
+        <p:spPr>
+          <a:xfrm>
+            <a:off x="8869680" y="5971032"/>
+            <a:ext cx="384048" cy="384048"/>
+          </a:xfrm>
+          <a:prstGeom prst="ellipse">
+            <a:avLst/>
+          </a:prstGeom>
+          <a:solidFill>
+            <a:srgbClr val="1E375A"/>
+          </a:solidFill>
+          <a:ln w="12700">
+            <a:solidFill>
+              <a:srgbClr val="3B82F6"/>
+            </a:solidFill>
+          </a:ln>
+        </p:spPr>
+        <p:style>
+          <a:lnRef idx="1">
+            <a:schemeClr val="accent1"/>
+          </a:lnRef>
+          <a:fillRef idx="3">
+            <a:schemeClr val="accent1"/>
+          </a:fillRef>
+          <a:effectRef idx="2">
+            <a:schemeClr val="accent1"/>
+          </a:effectRef>
+          <a:fontRef idx="minor">
+            <a:schemeClr val="lt1"/>
+          </a:fontRef>
+        </p:style>
+        <p:txBody>
+          <a:bodyPr rtlCol="0" anchor="ctr"/>
+          <a:lstStyle/>
+          <a:p>
+            <a:pPr algn="ctr"/>
+          </a:p>
+        </p:txBody>
+      </p:sp>
+      <p:sp>
+        <p:nvSpPr>
+          <p:cNvPr id="41" name="TextBox 40"/>
+          <p:cNvSpPr txBox="1"/>
+          <p:nvPr/>
+        </p:nvSpPr>
+        <p:spPr>
+          <a:xfrm>
+            <a:off x="8823960" y="6409944"/>
+            <a:ext cx="1234440" cy="320040"/>
+          </a:xfrm>
+          <a:prstGeom prst="rect">
+            <a:avLst/>
+          </a:prstGeom>
+          <a:noFill/>
+        </p:spPr>
+        <p:txBody>
+          <a:bodyPr wrap="square" anchor="t">
+            <a:spAutoFit/>
+          </a:bodyPr>
+          <a:lstStyle/>
+          <a:p>
+            <a:pPr algn="ctr">
+              <a:defRPr sz="1100" b="0">
+                <a:solidFill>
+                  <a:srgbClr val="FFFFFF"/>
+                </a:solidFill>
+                <a:latin typeface="Microsoft YaHei"/>
+              </a:defRPr>
+            </a:pPr>
+            <a:r>
+              <a:t>推理延迟</a:t>
+            </a:r>
+          </a:p>
+        </p:txBody>
+      </p:sp>
+      <p:sp>
+        <p:nvSpPr>
+          <p:cNvPr id="42" name="Oval 41"/>
+          <p:cNvSpPr/>
+          <p:nvPr/>
+        </p:nvSpPr>
+        <p:spPr>
+          <a:xfrm>
+            <a:off x="10332720" y="5971032"/>
+            <a:ext cx="384048" cy="384048"/>
+          </a:xfrm>
+          <a:prstGeom prst="ellipse">
+            <a:avLst/>
+          </a:prstGeom>
+          <a:solidFill>
+            <a:srgbClr val="1E375A"/>
+          </a:solidFill>
+          <a:ln w="12700">
+            <a:solidFill>
+              <a:srgbClr val="3B82F6"/>
+            </a:solidFill>
+          </a:ln>
+        </p:spPr>
+        <p:style>
+          <a:lnRef idx="1">
+            <a:schemeClr val="accent1"/>
+          </a:lnRef>
+          <a:fillRef idx="3">
+            <a:schemeClr val="accent1"/>
+          </a:fillRef>
+          <a:effectRef idx="2">
+            <a:schemeClr val="accent1"/>
+          </a:effectRef>
+          <a:fontRef idx="minor">
+            <a:schemeClr val="lt1"/>
+          </a:fontRef>
+        </p:style>
+        <p:txBody>
+          <a:bodyPr rtlCol="0" anchor="ctr"/>
+          <a:lstStyle/>
+          <a:p>
+            <a:pPr algn="ctr"/>
+          </a:p>
+        </p:txBody>
+      </p:sp>
+      <p:sp>
+        <p:nvSpPr>
+          <p:cNvPr id="43" name="TextBox 42"/>
+          <p:cNvSpPr txBox="1"/>
+          <p:nvPr/>
+        </p:nvSpPr>
+        <p:spPr>
+          <a:xfrm>
+            <a:off x="10287000" y="6409944"/>
+            <a:ext cx="1234440" cy="320040"/>
+          </a:xfrm>
+          <a:prstGeom prst="rect">
+            <a:avLst/>
+          </a:prstGeom>
+          <a:noFill/>
+        </p:spPr>
+        <p:txBody>
+          <a:bodyPr wrap="square" anchor="t">
+            <a:spAutoFit/>
+          </a:bodyPr>
+          <a:lstStyle/>
+          <a:p>
+            <a:pPr algn="ctr">
+              <a:defRPr sz="1100" b="0">
+                <a:solidFill>
+                  <a:srgbClr val="FFFFFF"/>
+                </a:solidFill>
+                <a:latin typeface="Microsoft YaHei"/>
+              </a:defRPr>
+            </a:pPr>
+            <a:r>
+              <a:t>单位经济</a:t>
+            </a:r>
+          </a:p>
+        </p:txBody>
+      </p:sp>
+      <p:sp>
+        <p:nvSpPr>
+          <p:cNvPr id="44" name="Oval 43"/>
+          <p:cNvSpPr/>
+          <p:nvPr/>
+        </p:nvSpPr>
+        <p:spPr>
+          <a:xfrm>
+            <a:off x="11795760" y="5971032"/>
+            <a:ext cx="384048" cy="384048"/>
+          </a:xfrm>
+          <a:prstGeom prst="ellipse">
+            <a:avLst/>
+          </a:prstGeom>
+          <a:solidFill>
+            <a:srgbClr val="1E375A"/>
+          </a:solidFill>
+          <a:ln w="12700">
+            <a:solidFill>
+              <a:srgbClr val="3B82F6"/>
+            </a:solidFill>
+          </a:ln>
+        </p:spPr>
+        <p:style>
+          <a:lnRef idx="1">
+            <a:schemeClr val="accent1"/>
+          </a:lnRef>
+          <a:fillRef idx="3">
+            <a:schemeClr val="accent1"/>
+          </a:fillRef>
+          <a:effectRef idx="2">
+            <a:schemeClr val="accent1"/>
+          </a:effectRef>
+          <a:fontRef idx="minor">
+            <a:schemeClr val="lt1"/>
+          </a:fontRef>
+        </p:style>
+        <p:txBody>
+          <a:bodyPr rtlCol="0" anchor="ctr"/>
+          <a:lstStyle/>
+          <a:p>
+            <a:pPr algn="ctr"/>
+          </a:p>
+        </p:txBody>
+      </p:sp>
+      <p:sp>
+        <p:nvSpPr>
+          <p:cNvPr id="45" name="TextBox 44"/>
+          <p:cNvSpPr txBox="1"/>
+          <p:nvPr/>
+        </p:nvSpPr>
+        <p:spPr>
+          <a:xfrm>
+            <a:off x="11750040" y="6409944"/>
+            <a:ext cx="1234440" cy="320040"/>
+          </a:xfrm>
+          <a:prstGeom prst="rect">
+            <a:avLst/>
+          </a:prstGeom>
+          <a:noFill/>
+        </p:spPr>
+        <p:txBody>
+          <a:bodyPr wrap="square" anchor="t">
+            <a:spAutoFit/>
+          </a:bodyPr>
+          <a:lstStyle/>
+          <a:p>
+            <a:pPr algn="ctr">
+              <a:defRPr sz="1100" b="0">
+                <a:solidFill>
+                  <a:srgbClr val="FFFFFF"/>
+                </a:solidFill>
+                <a:latin typeface="Microsoft YaHei"/>
+              </a:defRPr>
+            </a:pPr>
+            <a:r>
+              <a:t>产品契合</a:t>
+            </a:r>
+          </a:p>
+        </p:txBody>
+      </p:sp>
     </p:spTree>
   </p:cSld>
   <p:clrMapOvr>

</xml_diff>